<commit_message>
Rewrite walkthrough deck in plain words
Same six slides, zero jargon: graph db / vector db / AI / person / approve.
The story of one document instead of a spec — waiting room instead of
staging, receipts instead of provenance, redo instead of requeue.

Co-Authored-By: Claude Fable 5 <noreply@anthropic.com>
Claude-Session: https://claude.ai/code/session_019Ahwu6z4i8eJ32ivnu5GA8
</commit_message>
<xml_diff>
--- a/docs/kgi-database-walkthrough.pptx
+++ b/docs/kgi-database-walkthrough.pptx
@@ -3145,7 +3145,7 @@
         </p:nvSpPr>
         <p:spPr>
           <a:xfrm>
-            <a:off x="548640" y="1554480"/>
+            <a:off x="548640" y="1417320"/>
             <a:ext cx="7315200" cy="320040"/>
           </a:xfrm>
           <a:prstGeom prst="rect">
@@ -3174,7 +3174,7 @@
                 </a:solidFill>
                 <a:latin typeface="Menlo"/>
               </a:rPr>
-              <a:t>ENGINEERING WALKTHROUGH</a:t>
+              <a:t>FOR ENGINEERS · 6 SLIDES</a:t>
             </a:r>
           </a:p>
         </p:txBody>
@@ -3187,8 +3187,8 @@
         </p:nvSpPr>
         <p:spPr>
           <a:xfrm>
-            <a:off x="548640" y="1920240"/>
-            <a:ext cx="10972800" cy="1463040"/>
+            <a:off x="548640" y="1783080"/>
+            <a:ext cx="11155680" cy="1371600"/>
           </a:xfrm>
           <a:prstGeom prst="rect">
             <a:avLst/>
@@ -3210,22 +3210,13 @@
               </a:spcAft>
             </a:pPr>
             <a:r>
-              <a:rPr sz="4000" b="1">
-                <a:solidFill>
-                  <a:srgbClr val="0B7E99"/>
-                </a:solidFill>
-                <a:latin typeface="Helvetica Neue"/>
-              </a:rPr>
-              <a:t>kgi</a:t>
-            </a:r>
-            <a:r>
-              <a:rPr sz="4000" b="1">
+              <a:rPr sz="3600" b="1">
                 <a:solidFill>
                   <a:srgbClr val="0E1116"/>
                 </a:solidFill>
                 <a:latin typeface="Helvetica Neue"/>
               </a:rPr>
-              <a:t> — ingestion &amp; query, database by database</a:t>
+              <a:t>Documents in, trusted knowledge graph out</a:t>
             </a:r>
           </a:p>
         </p:txBody>
@@ -3238,8 +3229,8 @@
         </p:nvSpPr>
         <p:spPr>
           <a:xfrm>
-            <a:off x="548640" y="3200400"/>
-            <a:ext cx="10515600" cy="822960"/>
+            <a:off x="548640" y="2880360"/>
+            <a:ext cx="10789920" cy="1371600"/>
           </a:xfrm>
           <a:prstGeom prst="rect">
             <a:avLst/>
@@ -3254,20 +3245,39 @@
           <a:p>
             <a:pPr algn="l">
               <a:lnSpc>
-                <a:spcPct val="115000"/>
+                <a:spcPct val="120000"/>
               </a:lnSpc>
               <a:spcAft>
                 <a:spcPts val="400"/>
               </a:spcAft>
             </a:pPr>
             <a:r>
+              <a:rPr sz="1500" b="1">
+                <a:solidFill>
+                  <a:srgbClr val="0E1116"/>
+                </a:solidFill>
+                <a:latin typeface="Helvetica Neue"/>
+              </a:rPr>
+              <a:t>The whole system in one sentence:</a:t>
+            </a:r>
+          </a:p>
+          <a:p>
+            <a:pPr algn="l">
+              <a:lnSpc>
+                <a:spcPct val="120000"/>
+              </a:lnSpc>
+              <a:spcAft>
+                <a:spcPts val="400"/>
+              </a:spcAft>
+            </a:pPr>
+            <a:r>
               <a:rPr sz="1500" b="0">
                 <a:solidFill>
                   <a:srgbClr val="48505C"/>
                 </a:solidFill>
                 <a:latin typeface="Helvetica Neue"/>
               </a:rPr>
-              <a:t>An LLM writes knowledge, a human approves it, and exactly one code path mutates the graph. This deck shows which store is read and written at every step of ingest, ask, and find.</a:t>
+              <a:t>An AI reads documents and proposes facts. A person approves or rejects each one. Only approved facts enter the graph. Then anyone can search it or ask it questions.</a:t>
             </a:r>
           </a:p>
         </p:txBody>
@@ -3280,8 +3290,8 @@
         </p:nvSpPr>
         <p:spPr>
           <a:xfrm>
-            <a:off x="548640" y="4297680"/>
-            <a:ext cx="1945843" cy="310896"/>
+            <a:off x="548640" y="4480560"/>
+            <a:ext cx="2299716" cy="329184"/>
           </a:xfrm>
           <a:prstGeom prst="roundRect">
             <a:avLst>
@@ -3313,12 +3323,12 @@
           </a:fontRef>
         </p:style>
         <p:txBody>
-          <a:bodyPr rtlCol="0" anchor="ctr" wrap="square" lIns="109728" rIns="109728" tIns="64008" bIns="64008"/>
+          <a:bodyPr rtlCol="0" anchor="ctr" wrap="square" lIns="128016" rIns="128016" tIns="73152" bIns="73152"/>
           <a:lstStyle/>
           <a:p>
             <a:pPr algn="ctr">
               <a:spcAft>
-                <a:spcPts val="200"/>
+                <a:spcPts val="300"/>
               </a:spcAft>
             </a:pPr>
             <a:r>
@@ -3328,7 +3338,7 @@
                 </a:solidFill>
                 <a:latin typeface="Menlo"/>
               </a:rPr>
-              <a:t>NEO4J — system of record</a:t>
+              <a:t>graph db (Neo4j) — the data</a:t>
             </a:r>
           </a:p>
         </p:txBody>
@@ -3341,8 +3351,8 @@
         </p:nvSpPr>
         <p:spPr>
           <a:xfrm>
-            <a:off x="2659075" y="4297680"/>
-            <a:ext cx="2320747" cy="310896"/>
+            <a:off x="3012948" y="4480560"/>
+            <a:ext cx="3387852" cy="329184"/>
           </a:xfrm>
           <a:prstGeom prst="roundRect">
             <a:avLst>
@@ -3374,12 +3384,12 @@
           </a:fontRef>
         </p:style>
         <p:txBody>
-          <a:bodyPr rtlCol="0" anchor="ctr" wrap="square" lIns="109728" rIns="109728" tIns="64008" bIns="64008"/>
+          <a:bodyPr rtlCol="0" anchor="ctr" wrap="square" lIns="128016" rIns="128016" tIns="73152" bIns="73152"/>
           <a:lstStyle/>
           <a:p>
             <a:pPr algn="ctr">
               <a:spcAft>
-                <a:spcPts val="200"/>
+                <a:spcPts val="300"/>
               </a:spcAft>
             </a:pPr>
             <a:r>
@@ -3389,7 +3399,7 @@
                 </a:solidFill>
                 <a:latin typeface="Menlo"/>
               </a:rPr>
-              <a:t>QDRANT — 3 vector collections</a:t>
+              <a:t>vector db (Qdrant) — finds similar things</a:t>
             </a:r>
           </a:p>
         </p:txBody>
@@ -3402,8 +3412,8 @@
         </p:nvSpPr>
         <p:spPr>
           <a:xfrm>
-            <a:off x="5144414" y="4297680"/>
-            <a:ext cx="1795881" cy="310896"/>
+            <a:off x="6565392" y="4480560"/>
+            <a:ext cx="2377440" cy="329184"/>
           </a:xfrm>
           <a:prstGeom prst="roundRect">
             <a:avLst>
@@ -3415,7 +3425,7 @@
           </a:solidFill>
           <a:ln w="9525">
             <a:solidFill>
-              <a:srgbClr val="848D9B"/>
+              <a:srgbClr val="CFD5DB"/>
             </a:solidFill>
           </a:ln>
           <a:effectLst/>
@@ -3435,22 +3445,22 @@
           </a:fontRef>
         </p:style>
         <p:txBody>
-          <a:bodyPr rtlCol="0" anchor="ctr" wrap="square" lIns="109728" rIns="109728" tIns="64008" bIns="64008"/>
+          <a:bodyPr rtlCol="0" anchor="ctr" wrap="square" lIns="128016" rIns="128016" tIns="73152" bIns="73152"/>
           <a:lstStyle/>
           <a:p>
             <a:pPr algn="ctr">
               <a:spcAft>
-                <a:spcPts val="200"/>
+                <a:spcPts val="300"/>
               </a:spcAft>
             </a:pPr>
             <a:r>
               <a:rPr sz="1000" b="1">
                 <a:solidFill>
-                  <a:srgbClr val="48505C"/>
+                  <a:srgbClr val="848D9B"/>
                 </a:solidFill>
                 <a:latin typeface="Menlo"/>
               </a:rPr>
-              <a:t>POSTGRES — parked runs</a:t>
+              <a:t>Postgres — saves paused runs</a:t>
             </a:r>
           </a:p>
         </p:txBody>
@@ -3463,8 +3473,8 @@
         </p:nvSpPr>
         <p:spPr>
           <a:xfrm>
-            <a:off x="7104887" y="4297680"/>
-            <a:ext cx="1420977" cy="310896"/>
+            <a:off x="9107424" y="4480560"/>
+            <a:ext cx="2066544" cy="329184"/>
           </a:xfrm>
           <a:prstGeom prst="roundRect">
             <a:avLst>
@@ -3476,7 +3486,7 @@
           </a:solidFill>
           <a:ln w="9525">
             <a:solidFill>
-              <a:srgbClr val="848D9B"/>
+              <a:srgbClr val="CFD5DB"/>
             </a:solidFill>
           </a:ln>
           <a:effectLst/>
@@ -3496,22 +3506,22 @@
           </a:fontRef>
         </p:style>
         <p:txBody>
-          <a:bodyPr rtlCol="0" anchor="ctr" wrap="square" lIns="109728" rIns="109728" tIns="64008" bIns="64008"/>
+          <a:bodyPr rtlCol="0" anchor="ctr" wrap="square" lIns="128016" rIns="128016" tIns="73152" bIns="73152"/>
           <a:lstStyle/>
           <a:p>
             <a:pPr algn="ctr">
               <a:spcAft>
-                <a:spcPts val="200"/>
+                <a:spcPts val="300"/>
               </a:spcAft>
             </a:pPr>
             <a:r>
               <a:rPr sz="1000" b="1">
                 <a:solidFill>
-                  <a:srgbClr val="48505C"/>
+                  <a:srgbClr val="848D9B"/>
                 </a:solidFill>
                 <a:latin typeface="Menlo"/>
               </a:rPr>
-              <a:t>LANGFUSE — traces</a:t>
+              <a:t>Langfuse — logs AI calls</a:t>
             </a:r>
           </a:p>
         </p:txBody>
@@ -3553,7 +3563,7 @@
                 </a:solidFill>
                 <a:latin typeface="Menlo"/>
               </a:rPr>
-              <a:t>kgi · working prototype · slides generated from the live implementation</a:t>
+              <a:t>every claim on these slides is how the code works today</a:t>
             </a:r>
           </a:p>
         </p:txBody>
@@ -3657,7 +3667,7 @@
                 </a:solidFill>
                 <a:latin typeface="Menlo"/>
               </a:rPr>
-              <a:t>01 · The cast</a:t>
+              <a:t>01 · The databases</a:t>
             </a:r>
           </a:p>
         </p:txBody>
@@ -3699,7 +3709,7 @@
                 </a:solidFill>
                 <a:latin typeface="Helvetica Neue"/>
               </a:rPr>
-              <a:t>Four stores, one writer</a:t>
+              <a:t>Two databases that matter, two helpers</a:t>
             </a:r>
           </a:p>
         </p:txBody>
@@ -3745,12 +3755,12 @@
           </a:fontRef>
         </p:style>
         <p:txBody>
-          <a:bodyPr rtlCol="0" anchor="t" wrap="square" lIns="109728" rIns="109728" tIns="64008" bIns="64008"/>
+          <a:bodyPr rtlCol="0" anchor="t" wrap="square" lIns="128016" rIns="128016" tIns="73152" bIns="73152"/>
           <a:lstStyle/>
           <a:p>
             <a:pPr algn="l">
               <a:spcAft>
-                <a:spcPts val="200"/>
+                <a:spcPts val="300"/>
               </a:spcAft>
             </a:pPr>
             <a:r>
@@ -3760,13 +3770,13 @@
                 </a:solidFill>
                 <a:latin typeface="Menlo"/>
               </a:rPr>
-              <a:t>NEO4J</a:t>
+              <a:t>graph db  (Neo4j)</a:t>
             </a:r>
           </a:p>
           <a:p>
             <a:pPr algn="l">
               <a:spcAft>
-                <a:spcPts val="200"/>
+                <a:spcPts val="300"/>
               </a:spcAft>
             </a:pPr>
             <a:r>
@@ -3776,17 +3786,17 @@
                 </a:solidFill>
                 <a:latin typeface="Helvetica Neue"/>
               </a:rPr>
-              <a:t>System of record — if lost, total loss</a:t>
+              <a:t>This is the actual knowledge. Lose it, lose everything.</a:t>
             </a:r>
           </a:p>
           <a:p>
             <a:pPr algn="l">
               <a:spcAft>
-                <a:spcPts val="200"/>
-              </a:spcAft>
-            </a:pPr>
-            <a:r>
-              <a:rPr sz="1050" b="0">
+                <a:spcPts val="300"/>
+              </a:spcAft>
+            </a:pPr>
+            <a:r>
+              <a:rPr sz="400" b="0">
                 <a:solidFill>
                   <a:srgbClr val="48505C"/>
                 </a:solidFill>
@@ -3798,7 +3808,7 @@
           <a:p>
             <a:pPr algn="l">
               <a:spcAft>
-                <a:spcPts val="200"/>
+                <a:spcPts val="300"/>
               </a:spcAft>
             </a:pPr>
             <a:r>
@@ -3817,13 +3827,13 @@
                 </a:solidFill>
                 <a:latin typeface="Helvetica Neue"/>
               </a:rPr>
-              <a:t>Entities + one-line descriptions</a:t>
+              <a:t>Things (people, companies, places…), each with a one-line description</a:t>
             </a:r>
           </a:p>
           <a:p>
             <a:pPr algn="l">
               <a:spcAft>
-                <a:spcPts val="200"/>
+                <a:spcPts val="300"/>
               </a:spcAft>
             </a:pPr>
             <a:r>
@@ -3842,13 +3852,13 @@
                 </a:solidFill>
                 <a:latin typeface="Helvetica Neue"/>
               </a:rPr>
-              <a:t>Bi-temporal facts (valid_from/to) + every source's verbatim quotes</a:t>
+              <a:t>Facts between things — with start/end dates, so old facts close instead of being deleted</a:t>
             </a:r>
           </a:p>
           <a:p>
             <a:pPr algn="l">
               <a:spcAft>
-                <a:spcPts val="200"/>
+                <a:spcPts val="300"/>
               </a:spcAft>
             </a:pPr>
             <a:r>
@@ -3867,13 +3877,13 @@
                 </a:solidFill>
                 <a:latin typeface="Helvetica Neue"/>
               </a:rPr>
-              <a:t>Staged patches (JSON blob — never graph structure)</a:t>
+              <a:t>The exact sentence(s) each fact came from, one per source document</a:t>
             </a:r>
           </a:p>
           <a:p>
             <a:pPr algn="l">
               <a:spcAft>
-                <a:spcPts val="200"/>
+                <a:spcPts val="300"/>
               </a:spcAft>
             </a:pPr>
             <a:r>
@@ -3892,13 +3902,13 @@
                 </a:solidFill>
                 <a:latin typeface="Helvetica Neue"/>
               </a:rPr>
-              <a:t>Commit ledger · review decisions · doc hashes · SAME_AS merge links</a:t>
+              <a:t>Who approved every fact, when, from which document</a:t>
             </a:r>
           </a:p>
           <a:p>
             <a:pPr algn="l">
               <a:spcAft>
-                <a:spcPts val="200"/>
+                <a:spcPts val="300"/>
               </a:spcAft>
             </a:pPr>
             <a:r>
@@ -3917,7 +3927,7 @@
                 </a:solidFill>
                 <a:latin typeface="Helvetica Neue"/>
               </a:rPr>
-              <a:t>Lucene full-text indexes — maintained by Neo4j on every write</a:t>
+              <a:t>Also holds the waiting room: proposed facts sit here as plain JSON until a person decides</a:t>
             </a:r>
           </a:p>
         </p:txBody>
@@ -3963,12 +3973,12 @@
           </a:fontRef>
         </p:style>
         <p:txBody>
-          <a:bodyPr rtlCol="0" anchor="t" wrap="square" lIns="109728" rIns="109728" tIns="64008" bIns="64008"/>
+          <a:bodyPr rtlCol="0" anchor="t" wrap="square" lIns="128016" rIns="128016" tIns="73152" bIns="73152"/>
           <a:lstStyle/>
           <a:p>
             <a:pPr algn="l">
               <a:spcAft>
-                <a:spcPts val="200"/>
+                <a:spcPts val="300"/>
               </a:spcAft>
             </a:pPr>
             <a:r>
@@ -3978,13 +3988,13 @@
                 </a:solidFill>
                 <a:latin typeface="Menlo"/>
               </a:rPr>
-              <a:t>QDRANT</a:t>
+              <a:t>vector db  (Qdrant)</a:t>
             </a:r>
           </a:p>
           <a:p>
             <a:pPr algn="l">
               <a:spcAft>
-                <a:spcPts val="200"/>
+                <a:spcPts val="300"/>
               </a:spcAft>
             </a:pPr>
             <a:r>
@@ -3994,17 +4004,17 @@
                 </a:solidFill>
                 <a:latin typeface="Helvetica Neue"/>
               </a:rPr>
-              <a:t>Similarity index — derived, rebuildable in minutes</a:t>
+              <a:t>Only for similarity search. Delete it any time — one script rebuilds it from the graph db.</a:t>
             </a:r>
           </a:p>
           <a:p>
             <a:pPr algn="l">
               <a:spcAft>
-                <a:spcPts val="200"/>
-              </a:spcAft>
-            </a:pPr>
-            <a:r>
-              <a:rPr sz="1050" b="0">
+                <a:spcPts val="300"/>
+              </a:spcAft>
+            </a:pPr>
+            <a:r>
+              <a:rPr sz="400" b="0">
                 <a:solidFill>
                   <a:srgbClr val="48505C"/>
                 </a:solidFill>
@@ -4016,7 +4026,7 @@
           <a:p>
             <a:pPr algn="l">
               <a:spcAft>
-                <a:spcPts val="200"/>
+                <a:spcPts val="300"/>
               </a:spcAft>
             </a:pPr>
             <a:r>
@@ -4035,13 +4045,13 @@
                 </a:solidFill>
                 <a:latin typeface="Helvetica Neue"/>
               </a:rPr>
-              <a:t>kgi-entities — name + description (384-dim, embedded locally)</a:t>
+              <a:t>“Is 'Acme Corp' the same as 'Acme Corporation'?” — similar names &amp; descriptions</a:t>
             </a:r>
           </a:p>
           <a:p>
             <a:pPr algn="l">
               <a:spcAft>
-                <a:spcPts val="200"/>
+                <a:spcPts val="300"/>
               </a:spcAft>
             </a:pPr>
             <a:r>
@@ -4060,13 +4070,13 @@
                 </a:solidFill>
                 <a:latin typeface="Helvetica Neue"/>
               </a:rPr>
-              <a:t>kgi-predicates — phrase vectors for paraphrase normalization</a:t>
+              <a:t>“Is 'is CEO of' the same as 'chief executive of'?” — similar wordings</a:t>
             </a:r>
           </a:p>
           <a:p>
             <a:pPr algn="l">
               <a:spcAft>
-                <a:spcPts val="200"/>
+                <a:spcPts val="300"/>
               </a:spcAft>
             </a:pPr>
             <a:r>
@@ -4085,13 +4095,13 @@
                 </a:solidFill>
                 <a:latin typeface="Helvetica Neue"/>
               </a:rPr>
-              <a:t>kgi-facts — one point per committed fact: rendering + window + quotes</a:t>
+              <a:t>“Which stored facts sound like this question?” — similar facts</a:t>
             </a:r>
           </a:p>
           <a:p>
             <a:pPr algn="l">
               <a:spcAft>
-                <a:spcPts val="200"/>
+                <a:spcPts val="300"/>
               </a:spcAft>
             </a:pPr>
             <a:r>
@@ -4110,32 +4120,7 @@
                 </a:solidFill>
                 <a:latin typeface="Helvetica Neue"/>
               </a:rPr>
-              <a:t>Written only AFTER approval; staged candidates never indexed</a:t>
-            </a:r>
-          </a:p>
-          <a:p>
-            <a:pPr algn="l">
-              <a:spcAft>
-                <a:spcPts val="200"/>
-              </a:spcAft>
-            </a:pPr>
-            <a:r>
-              <a:rPr sz="950" b="0">
-                <a:solidFill>
-                  <a:srgbClr val="6D4FC4"/>
-                </a:solidFill>
-                <a:latin typeface="Helvetica Neue"/>
-              </a:rPr>
-              <a:t>▸ </a:t>
-            </a:r>
-            <a:r>
-              <a:rPr sz="950" b="0">
-                <a:solidFill>
-                  <a:srgbClr val="48505C"/>
-                </a:solidFill>
-                <a:latin typeface="Helvetica Neue"/>
-              </a:rPr>
-              <a:t>scripts/reindex_vectors.py rebuilds all three from Neo4j</a:t>
+              <a:t>Updated only after a person approves — proposals are never searchable</a:t>
             </a:r>
           </a:p>
         </p:txBody>
@@ -4181,12 +4166,12 @@
           </a:fontRef>
         </p:style>
         <p:txBody>
-          <a:bodyPr rtlCol="0" anchor="t" wrap="square" lIns="109728" rIns="109728" tIns="64008" bIns="64008"/>
+          <a:bodyPr rtlCol="0" anchor="t" wrap="square" lIns="128016" rIns="128016" tIns="73152" bIns="73152"/>
           <a:lstStyle/>
           <a:p>
             <a:pPr algn="l">
               <a:spcAft>
-                <a:spcPts val="200"/>
+                <a:spcPts val="300"/>
               </a:spcAft>
             </a:pPr>
             <a:r>
@@ -4196,13 +4181,13 @@
                 </a:solidFill>
                 <a:latin typeface="Menlo"/>
               </a:rPr>
-              <a:t>POSTGRES</a:t>
+              <a:t>Postgres</a:t>
             </a:r>
           </a:p>
           <a:p>
             <a:pPr algn="l">
               <a:spcAft>
-                <a:spcPts val="200"/>
+                <a:spcPts val="300"/>
               </a:spcAft>
             </a:pPr>
             <a:r>
@@ -4212,17 +4197,17 @@
                 </a:solidFill>
                 <a:latin typeface="Helvetica Neue"/>
               </a:rPr>
-              <a:t>Durable execution</a:t>
+              <a:t>One job.</a:t>
             </a:r>
           </a:p>
           <a:p>
             <a:pPr algn="l">
               <a:spcAft>
-                <a:spcPts val="200"/>
-              </a:spcAft>
-            </a:pPr>
-            <a:r>
-              <a:rPr sz="1050" b="0">
+                <a:spcPts val="300"/>
+              </a:spcAft>
+            </a:pPr>
+            <a:r>
+              <a:rPr sz="400" b="0">
                 <a:solidFill>
                   <a:srgbClr val="48505C"/>
                 </a:solidFill>
@@ -4234,7 +4219,7 @@
           <a:p>
             <a:pPr algn="l">
               <a:spcAft>
-                <a:spcPts val="200"/>
+                <a:spcPts val="300"/>
               </a:spcAft>
             </a:pPr>
             <a:r>
@@ -4253,13 +4238,13 @@
                 </a:solidFill>
                 <a:latin typeface="Helvetica Neue"/>
               </a:rPr>
-              <a:t>LangGraph checkpoints of runs parked at the review gate</a:t>
+              <a:t>When a run stops to wait for human review, its state is saved here</a:t>
             </a:r>
           </a:p>
           <a:p>
             <a:pPr algn="l">
               <a:spcAft>
-                <a:spcPts val="200"/>
+                <a:spcPts val="300"/>
               </a:spcAft>
             </a:pPr>
             <a:r>
@@ -4278,32 +4263,7 @@
                 </a:solidFill>
                 <a:latin typeface="Helvetica Neue"/>
               </a:rPr>
-              <a:t>A parked run survives reboots for days; CLI and browser resume the same run</a:t>
-            </a:r>
-          </a:p>
-          <a:p>
-            <a:pPr algn="l">
-              <a:spcAft>
-                <a:spcPts val="200"/>
-              </a:spcAft>
-            </a:pPr>
-            <a:r>
-              <a:rPr sz="950" b="0">
-                <a:solidFill>
-                  <a:srgbClr val="48505C"/>
-                </a:solidFill>
-                <a:latin typeface="Helvetica Neue"/>
-              </a:rPr>
-              <a:t>▸ </a:t>
-            </a:r>
-            <a:r>
-              <a:rPr sz="950" b="0">
-                <a:solidFill>
-                  <a:srgbClr val="48505C"/>
-                </a:solidFill>
-                <a:latin typeface="Helvetica Neue"/>
-              </a:rPr>
-              <a:t>If lost: parked runs only — patches survive in Neo4j</a:t>
+              <a:t>So the wait can last a week, laptops can reboot, and the run still resumes</a:t>
             </a:r>
           </a:p>
         </p:txBody>
@@ -4349,12 +4309,12 @@
           </a:fontRef>
         </p:style>
         <p:txBody>
-          <a:bodyPr rtlCol="0" anchor="t" wrap="square" lIns="109728" rIns="109728" tIns="64008" bIns="64008"/>
+          <a:bodyPr rtlCol="0" anchor="t" wrap="square" lIns="128016" rIns="128016" tIns="73152" bIns="73152"/>
           <a:lstStyle/>
           <a:p>
             <a:pPr algn="l">
               <a:spcAft>
-                <a:spcPts val="200"/>
+                <a:spcPts val="300"/>
               </a:spcAft>
             </a:pPr>
             <a:r>
@@ -4364,13 +4324,13 @@
                 </a:solidFill>
                 <a:latin typeface="Menlo"/>
               </a:rPr>
-              <a:t>LANGFUSE</a:t>
+              <a:t>Langfuse</a:t>
             </a:r>
           </a:p>
           <a:p>
             <a:pPr algn="l">
               <a:spcAft>
-                <a:spcPts val="200"/>
+                <a:spcPts val="300"/>
               </a:spcAft>
             </a:pPr>
             <a:r>
@@ -4380,17 +4340,17 @@
                 </a:solidFill>
                 <a:latin typeface="Helvetica Neue"/>
               </a:rPr>
-              <a:t>Observability — fail-open</a:t>
+              <a:t>One job.</a:t>
             </a:r>
           </a:p>
           <a:p>
             <a:pPr algn="l">
               <a:spcAft>
-                <a:spcPts val="200"/>
-              </a:spcAft>
-            </a:pPr>
-            <a:r>
-              <a:rPr sz="1050" b="0">
+                <a:spcPts val="300"/>
+              </a:spcAft>
+            </a:pPr>
+            <a:r>
+              <a:rPr sz="400" b="0">
                 <a:solidFill>
                   <a:srgbClr val="48505C"/>
                 </a:solidFill>
@@ -4402,7 +4362,7 @@
           <a:p>
             <a:pPr algn="l">
               <a:spcAft>
-                <a:spcPts val="200"/>
+                <a:spcPts val="300"/>
               </a:spcAft>
             </a:pPr>
             <a:r>
@@ -4421,13 +4381,13 @@
                 </a:solidFill>
                 <a:latin typeface="Helvetica Neue"/>
               </a:rPr>
-              <a:t>One trace per command; every LLM generation with prompt, output, tokens</a:t>
+              <a:t>Every AI call is logged: prompt, answer, cost</a:t>
             </a:r>
           </a:p>
           <a:p>
             <a:pPr algn="l">
               <a:spcAft>
-                <a:spcPts val="200"/>
+                <a:spcPts val="300"/>
               </a:spcAft>
             </a:pPr>
             <a:r>
@@ -4446,32 +4406,7 @@
                 </a:solidFill>
                 <a:latin typeface="Helvetica Neue"/>
               </a:rPr>
-              <a:t>All four LLM roles (extract, dedup judge, conflict judge, composer) go through one traced entry point</a:t>
-            </a:r>
-          </a:p>
-          <a:p>
-            <a:pPr algn="l">
-              <a:spcAft>
-                <a:spcPts val="200"/>
-              </a:spcAft>
-            </a:pPr>
-            <a:r>
-              <a:rPr sz="950" b="0">
-                <a:solidFill>
-                  <a:srgbClr val="48505C"/>
-                </a:solidFill>
-                <a:latin typeface="Helvetica Neue"/>
-              </a:rPr>
-              <a:t>▸ </a:t>
-            </a:r>
-            <a:r>
-              <a:rPr sz="950" b="0">
-                <a:solidFill>
-                  <a:srgbClr val="48505C"/>
-                </a:solidFill>
-                <a:latin typeface="Helvetica Neue"/>
-              </a:rPr>
-              <a:t>If lost: telemetry only</a:t>
+              <a:t>When extraction does something weird, you look here</a:t>
             </a:r>
           </a:p>
         </p:txBody>
@@ -4517,12 +4452,12 @@
           </a:fontRef>
         </p:style>
         <p:txBody>
-          <a:bodyPr rtlCol="0" anchor="ctr" wrap="square" lIns="109728" rIns="109728" tIns="64008" bIns="64008"/>
+          <a:bodyPr rtlCol="0" anchor="ctr" wrap="square" lIns="128016" rIns="128016" tIns="73152" bIns="73152"/>
           <a:lstStyle/>
           <a:p>
             <a:pPr algn="l">
               <a:spcAft>
-                <a:spcPts val="200"/>
+                <a:spcPts val="300"/>
               </a:spcAft>
             </a:pPr>
             <a:r>
@@ -4532,16 +4467,16 @@
                 </a:solidFill>
                 <a:latin typeface="Menlo"/>
               </a:rPr>
-              <a:t>THE ONE RULE   </a:t>
-            </a:r>
-            <a:r>
-              <a:rPr sz="1100" b="0">
+              <a:t>RULE #1   </a:t>
+            </a:r>
+            <a:r>
+              <a:rPr sz="1150" b="0">
                 <a:solidFill>
                   <a:srgbClr val="0E1116"/>
                 </a:solidFill>
                 <a:latin typeface="Helvetica Neue"/>
               </a:rPr>
-              <a:t>only approved commits write the main graph. Everything the LLM produces goes to staging first; a fact that never passes review never influences anything.</a:t>
+              <a:t>the AI never writes to the graph db. The only thing that writes facts is the approve button.</a:t>
             </a:r>
           </a:p>
         </p:txBody>
@@ -4645,7 +4580,7 @@
                 </a:solidFill>
                 <a:latin typeface="Menlo"/>
               </a:rPr>
-              <a:t>02 · Ingestion — before the gate</a:t>
+              <a:t>02 · Ingesting a document — part 1</a:t>
             </a:r>
           </a:p>
         </p:txBody>
@@ -4687,7 +4622,7 @@
                 </a:solidFill>
                 <a:latin typeface="Helvetica Neue"/>
               </a:rPr>
-              <a:t>s1–s7 · build the patch (reads only, one staging write)</a:t>
+              <a:t>The AI reads and proposes. Nothing is written yet.</a:t>
             </a:r>
           </a:p>
         </p:txBody>
@@ -4700,8 +4635,8 @@
         </p:nvSpPr>
         <p:spPr>
           <a:xfrm>
-            <a:off x="548640" y="1389888"/>
-            <a:ext cx="384048" cy="256032"/>
+            <a:off x="548640" y="1316736"/>
+            <a:ext cx="310896" cy="310896"/>
           </a:xfrm>
           <a:prstGeom prst="roundRect">
             <a:avLst>
@@ -4733,22 +4668,22 @@
           </a:fontRef>
         </p:style>
         <p:txBody>
-          <a:bodyPr rtlCol="0" anchor="ctr" wrap="square" lIns="109728" rIns="109728" tIns="64008" bIns="64008"/>
+          <a:bodyPr rtlCol="0" anchor="ctr" wrap="square" lIns="128016" rIns="128016" tIns="73152" bIns="73152"/>
           <a:lstStyle/>
           <a:p>
             <a:pPr algn="ctr">
               <a:spcAft>
-                <a:spcPts val="200"/>
-              </a:spcAft>
-            </a:pPr>
-            <a:r>
-              <a:rPr sz="850" b="1">
-                <a:solidFill>
-                  <a:srgbClr val="48505C"/>
+                <a:spcPts val="300"/>
+              </a:spcAft>
+            </a:pPr>
+            <a:r>
+              <a:rPr sz="1100" b="1">
+                <a:solidFill>
+                  <a:srgbClr val="0E1116"/>
                 </a:solidFill>
                 <a:latin typeface="Menlo"/>
               </a:rPr>
-              <a:t>s1</a:t>
+              <a:t>1</a:t>
             </a:r>
           </a:p>
         </p:txBody>
@@ -4761,8 +4696,8 @@
         </p:nvSpPr>
         <p:spPr>
           <a:xfrm>
-            <a:off x="1042415" y="1298448"/>
-            <a:ext cx="1417320" cy="457200"/>
+            <a:off x="987552" y="1280160"/>
+            <a:ext cx="2148840" cy="640080"/>
           </a:xfrm>
           <a:prstGeom prst="rect">
             <a:avLst/>
@@ -4777,20 +4712,20 @@
           <a:p>
             <a:pPr algn="l">
               <a:lnSpc>
-                <a:spcPct val="100000"/>
+                <a:spcPct val="95000"/>
               </a:lnSpc>
               <a:spcAft>
-                <a:spcPts val="400"/>
-              </a:spcAft>
-            </a:pPr>
-            <a:r>
-              <a:rPr sz="1250" b="1">
+                <a:spcPts val="0"/>
+              </a:spcAft>
+            </a:pPr>
+            <a:r>
+              <a:rPr sz="1150" b="1">
                 <a:solidFill>
                   <a:srgbClr val="0E1116"/>
                 </a:solidFill>
                 <a:latin typeface="Helvetica Neue"/>
               </a:rPr>
-              <a:t>Register</a:t>
+              <a:t>Fingerprint the file</a:t>
             </a:r>
           </a:p>
         </p:txBody>
@@ -4803,8 +4738,8 @@
         </p:nvSpPr>
         <p:spPr>
           <a:xfrm>
-            <a:off x="2487168" y="1280160"/>
-            <a:ext cx="7086600" cy="713232"/>
+            <a:off x="3246120" y="1261872"/>
+            <a:ext cx="6400800" cy="777240"/>
           </a:xfrm>
           <a:prstGeom prst="rect">
             <a:avLst/>
@@ -4819,20 +4754,20 @@
           <a:p>
             <a:pPr algn="l">
               <a:lnSpc>
-                <a:spcPct val="100000"/>
+                <a:spcPct val="98000"/>
               </a:lnSpc>
               <a:spcAft>
                 <a:spcPts val="0"/>
               </a:spcAft>
             </a:pPr>
             <a:r>
-              <a:rPr sz="950" b="0">
+              <a:rPr sz="900" b="0">
                 <a:solidFill>
                   <a:srgbClr val="48505C"/>
                 </a:solidFill>
                 <a:latin typeface="Helvetica Neue"/>
               </a:rPr>
-              <a:t>sha-256 the bytes; refuse if already committed or already parked at the gate (intake lock)</a:t>
+              <a:t>Hash the bytes. Already in the graph? Already waiting for review? Then stop right here.</a:t>
             </a:r>
           </a:p>
         </p:txBody>
@@ -4845,8 +4780,8 @@
         </p:nvSpPr>
         <p:spPr>
           <a:xfrm>
-            <a:off x="9710928" y="1371600"/>
-            <a:ext cx="671169" cy="256032"/>
+            <a:off x="9601200" y="1335024"/>
+            <a:ext cx="1367028" cy="274320"/>
           </a:xfrm>
           <a:prstGeom prst="roundRect">
             <a:avLst>
@@ -4878,22 +4813,22 @@
           </a:fontRef>
         </p:style>
         <p:txBody>
-          <a:bodyPr rtlCol="0" anchor="ctr" wrap="square" lIns="109728" rIns="109728" tIns="64008" bIns="64008"/>
+          <a:bodyPr rtlCol="0" anchor="ctr" wrap="square" lIns="128016" rIns="128016" tIns="73152" bIns="73152"/>
           <a:lstStyle/>
           <a:p>
             <a:pPr algn="ctr">
               <a:spcAft>
-                <a:spcPts val="200"/>
-              </a:spcAft>
-            </a:pPr>
-            <a:r>
-              <a:rPr sz="850" b="1">
+                <a:spcPts val="300"/>
+              </a:spcAft>
+            </a:pPr>
+            <a:r>
+              <a:rPr sz="800" b="1">
                 <a:solidFill>
                   <a:srgbClr val="0B7E99"/>
                 </a:solidFill>
                 <a:latin typeface="Menlo"/>
               </a:rPr>
-              <a:t>R neo4j</a:t>
+              <a:t>checks graph db</a:t>
             </a:r>
           </a:p>
         </p:txBody>
@@ -4906,8 +4841,8 @@
         </p:nvSpPr>
         <p:spPr>
           <a:xfrm>
-            <a:off x="548640" y="2112264"/>
-            <a:ext cx="384048" cy="256032"/>
+            <a:off x="548640" y="2066543"/>
+            <a:ext cx="310896" cy="310896"/>
           </a:xfrm>
           <a:prstGeom prst="roundRect">
             <a:avLst>
@@ -4939,22 +4874,22 @@
           </a:fontRef>
         </p:style>
         <p:txBody>
-          <a:bodyPr rtlCol="0" anchor="ctr" wrap="square" lIns="109728" rIns="109728" tIns="64008" bIns="64008"/>
+          <a:bodyPr rtlCol="0" anchor="ctr" wrap="square" lIns="128016" rIns="128016" tIns="73152" bIns="73152"/>
           <a:lstStyle/>
           <a:p>
             <a:pPr algn="ctr">
               <a:spcAft>
-                <a:spcPts val="200"/>
-              </a:spcAft>
-            </a:pPr>
-            <a:r>
-              <a:rPr sz="850" b="1">
-                <a:solidFill>
-                  <a:srgbClr val="48505C"/>
+                <a:spcPts val="300"/>
+              </a:spcAft>
+            </a:pPr>
+            <a:r>
+              <a:rPr sz="1100" b="1">
+                <a:solidFill>
+                  <a:srgbClr val="0E1116"/>
                 </a:solidFill>
                 <a:latin typeface="Menlo"/>
               </a:rPr>
-              <a:t>s2</a:t>
+              <a:t>2</a:t>
             </a:r>
           </a:p>
         </p:txBody>
@@ -4967,8 +4902,8 @@
         </p:nvSpPr>
         <p:spPr>
           <a:xfrm>
-            <a:off x="1042415" y="2020824"/>
-            <a:ext cx="1417320" cy="457200"/>
+            <a:off x="987552" y="2029967"/>
+            <a:ext cx="2148840" cy="640080"/>
           </a:xfrm>
           <a:prstGeom prst="rect">
             <a:avLst/>
@@ -4983,20 +4918,20 @@
           <a:p>
             <a:pPr algn="l">
               <a:lnSpc>
-                <a:spcPct val="100000"/>
+                <a:spcPct val="95000"/>
               </a:lnSpc>
               <a:spcAft>
-                <a:spcPts val="400"/>
-              </a:spcAft>
-            </a:pPr>
-            <a:r>
-              <a:rPr sz="1250" b="1">
+                <a:spcPts val="0"/>
+              </a:spcAft>
+            </a:pPr>
+            <a:r>
+              <a:rPr sz="1150" b="1">
                 <a:solidFill>
                   <a:srgbClr val="0E1116"/>
                 </a:solidFill>
                 <a:latin typeface="Helvetica Neue"/>
               </a:rPr>
-              <a:t>Decompose</a:t>
+              <a:t>Split into paragraphs</a:t>
             </a:r>
           </a:p>
         </p:txBody>
@@ -5009,8 +4944,8 @@
         </p:nvSpPr>
         <p:spPr>
           <a:xfrm>
-            <a:off x="2487168" y="2002536"/>
-            <a:ext cx="7086600" cy="713232"/>
+            <a:off x="3246120" y="2011679"/>
+            <a:ext cx="6400800" cy="777240"/>
           </a:xfrm>
           <a:prstGeom prst="rect">
             <a:avLst/>
@@ -5025,20 +4960,20 @@
           <a:p>
             <a:pPr algn="l">
               <a:lnSpc>
-                <a:spcPct val="100000"/>
+                <a:spcPct val="98000"/>
               </a:lnSpc>
               <a:spcAft>
                 <a:spcPts val="0"/>
               </a:spcAft>
             </a:pPr>
             <a:r>
-              <a:rPr sz="950" b="0">
+              <a:rPr sz="900" b="0">
                 <a:solidFill>
                   <a:srgbClr val="48505C"/>
                 </a:solidFill>
                 <a:latin typeface="Helvetica Neue"/>
               </a:rPr>
-              <a:t>paragraphs become extraction units; headings ride along as context — no AI, no I/O</a:t>
+              <a:t>Each paragraph goes to the AI separately, with its section heading for context.</a:t>
             </a:r>
           </a:p>
         </p:txBody>
@@ -5051,8 +4986,8 @@
         </p:nvSpPr>
         <p:spPr>
           <a:xfrm>
-            <a:off x="9710928" y="2093976"/>
-            <a:ext cx="1345996" cy="256032"/>
+            <a:off x="9601200" y="2084831"/>
+            <a:ext cx="1056132" cy="274320"/>
           </a:xfrm>
           <a:prstGeom prst="roundRect">
             <a:avLst>
@@ -5084,22 +5019,22 @@
           </a:fontRef>
         </p:style>
         <p:txBody>
-          <a:bodyPr rtlCol="0" anchor="ctr" wrap="square" lIns="109728" rIns="109728" tIns="64008" bIns="64008"/>
+          <a:bodyPr rtlCol="0" anchor="ctr" wrap="square" lIns="128016" rIns="128016" tIns="73152" bIns="73152"/>
           <a:lstStyle/>
           <a:p>
             <a:pPr algn="ctr">
               <a:spcAft>
-                <a:spcPts val="200"/>
-              </a:spcAft>
-            </a:pPr>
-            <a:r>
-              <a:rPr sz="850" b="1">
-                <a:solidFill>
-                  <a:srgbClr val="48505C"/>
+                <a:spcPts val="300"/>
+              </a:spcAft>
+            </a:pPr>
+            <a:r>
+              <a:rPr sz="800" b="1">
+                <a:solidFill>
+                  <a:srgbClr val="848D9B"/>
                 </a:solidFill>
                 <a:latin typeface="Menlo"/>
               </a:rPr>
-              <a:t>no store touched</a:t>
+              <a:t>no database</a:t>
             </a:r>
           </a:p>
         </p:txBody>
@@ -5112,8 +5047,8 @@
         </p:nvSpPr>
         <p:spPr>
           <a:xfrm>
-            <a:off x="548640" y="2834640"/>
-            <a:ext cx="384048" cy="256032"/>
+            <a:off x="548640" y="2816351"/>
+            <a:ext cx="310896" cy="310896"/>
           </a:xfrm>
           <a:prstGeom prst="roundRect">
             <a:avLst>
@@ -5145,22 +5080,22 @@
           </a:fontRef>
         </p:style>
         <p:txBody>
-          <a:bodyPr rtlCol="0" anchor="ctr" wrap="square" lIns="109728" rIns="109728" tIns="64008" bIns="64008"/>
+          <a:bodyPr rtlCol="0" anchor="ctr" wrap="square" lIns="128016" rIns="128016" tIns="73152" bIns="73152"/>
           <a:lstStyle/>
           <a:p>
             <a:pPr algn="ctr">
               <a:spcAft>
-                <a:spcPts val="200"/>
-              </a:spcAft>
-            </a:pPr>
-            <a:r>
-              <a:rPr sz="850" b="1">
-                <a:solidFill>
-                  <a:srgbClr val="48505C"/>
+                <a:spcPts val="300"/>
+              </a:spcAft>
+            </a:pPr>
+            <a:r>
+              <a:rPr sz="1100" b="1">
+                <a:solidFill>
+                  <a:srgbClr val="0E1116"/>
                 </a:solidFill>
                 <a:latin typeface="Menlo"/>
               </a:rPr>
-              <a:t>s3</a:t>
+              <a:t>3</a:t>
             </a:r>
           </a:p>
         </p:txBody>
@@ -5173,8 +5108,8 @@
         </p:nvSpPr>
         <p:spPr>
           <a:xfrm>
-            <a:off x="1042415" y="2743200"/>
-            <a:ext cx="1417320" cy="457200"/>
+            <a:off x="987552" y="2779775"/>
+            <a:ext cx="2148840" cy="640080"/>
           </a:xfrm>
           <a:prstGeom prst="rect">
             <a:avLst/>
@@ -5189,20 +5124,20 @@
           <a:p>
             <a:pPr algn="l">
               <a:lnSpc>
-                <a:spcPct val="100000"/>
+                <a:spcPct val="95000"/>
               </a:lnSpc>
               <a:spcAft>
-                <a:spcPts val="400"/>
-              </a:spcAft>
-            </a:pPr>
-            <a:r>
-              <a:rPr sz="1250" b="1">
+                <a:spcPts val="0"/>
+              </a:spcAft>
+            </a:pPr>
+            <a:r>
+              <a:rPr sz="1150" b="1">
                 <a:solidFill>
                   <a:srgbClr val="0E1116"/>
                 </a:solidFill>
                 <a:latin typeface="Helvetica Neue"/>
               </a:rPr>
-              <a:t>Extract</a:t>
+              <a:t>AI pulls out the facts</a:t>
             </a:r>
           </a:p>
         </p:txBody>
@@ -5215,8 +5150,8 @@
         </p:nvSpPr>
         <p:spPr>
           <a:xfrm>
-            <a:off x="2487168" y="2724912"/>
-            <a:ext cx="7086600" cy="713232"/>
+            <a:off x="3246120" y="2761487"/>
+            <a:ext cx="6400800" cy="777240"/>
           </a:xfrm>
           <a:prstGeom prst="rect">
             <a:avLst/>
@@ -5231,20 +5166,20 @@
           <a:p>
             <a:pPr algn="l">
               <a:lnSpc>
-                <a:spcPct val="100000"/>
+                <a:spcPct val="98000"/>
               </a:lnSpc>
               <a:spcAft>
                 <a:spcPts val="0"/>
               </a:spcAft>
             </a:pPr>
             <a:r>
-              <a:rPr sz="950" b="0">
+              <a:rPr sz="900" b="0">
                 <a:solidFill>
                   <a:srgbClr val="48505C"/>
                 </a:solidFill>
                 <a:latin typeface="Helvetica Neue"/>
               </a:rPr>
-              <a:t>one LLM call per unit → entities (+ one-line description) and relations (+ verbatim quote)</a:t>
+              <a:t>One AI call per paragraph. It returns things + facts, each with the exact quote from the text, and a one-line description of every thing (“Basel — city where Acme is headquartered”).</a:t>
             </a:r>
           </a:p>
         </p:txBody>
@@ -5257,8 +5192,8 @@
         </p:nvSpPr>
         <p:spPr>
           <a:xfrm>
-            <a:off x="9710928" y="2816352"/>
-            <a:ext cx="371246" cy="256032"/>
+            <a:off x="9601200" y="2834639"/>
+            <a:ext cx="356616" cy="274320"/>
           </a:xfrm>
           <a:prstGeom prst="roundRect">
             <a:avLst>
@@ -5290,22 +5225,22 @@
           </a:fontRef>
         </p:style>
         <p:txBody>
-          <a:bodyPr rtlCol="0" anchor="ctr" wrap="square" lIns="109728" rIns="109728" tIns="64008" bIns="64008"/>
+          <a:bodyPr rtlCol="0" anchor="ctr" wrap="square" lIns="128016" rIns="128016" tIns="73152" bIns="73152"/>
           <a:lstStyle/>
           <a:p>
             <a:pPr algn="ctr">
               <a:spcAft>
-                <a:spcPts val="200"/>
-              </a:spcAft>
-            </a:pPr>
-            <a:r>
-              <a:rPr sz="850" b="1">
+                <a:spcPts val="300"/>
+              </a:spcAft>
+            </a:pPr>
+            <a:r>
+              <a:rPr sz="800" b="1">
                 <a:solidFill>
                   <a:srgbClr val="6D4FC4"/>
                 </a:solidFill>
                 <a:latin typeface="Menlo"/>
               </a:rPr>
-              <a:t>LLM</a:t>
+              <a:t>AI</a:t>
             </a:r>
           </a:p>
         </p:txBody>
@@ -5318,8 +5253,153 @@
         </p:nvSpPr>
         <p:spPr>
           <a:xfrm>
-            <a:off x="10155325" y="2816352"/>
-            <a:ext cx="671169" cy="256032"/>
+            <a:off x="548640" y="3566159"/>
+            <a:ext cx="310896" cy="310896"/>
+          </a:xfrm>
+          <a:prstGeom prst="roundRect">
+            <a:avLst>
+              <a:gd name="adj" fmla="val 50000"/>
+            </a:avLst>
+          </a:prstGeom>
+          <a:solidFill>
+            <a:srgbClr val="F2F4F6"/>
+          </a:solidFill>
+          <a:ln w="9525">
+            <a:solidFill>
+              <a:srgbClr val="CFD5DB"/>
+            </a:solidFill>
+          </a:ln>
+          <a:effectLst/>
+        </p:spPr>
+        <p:style>
+          <a:lnRef idx="1">
+            <a:schemeClr val="accent1"/>
+          </a:lnRef>
+          <a:fillRef idx="3">
+            <a:schemeClr val="accent1"/>
+          </a:fillRef>
+          <a:effectRef idx="2">
+            <a:schemeClr val="accent1"/>
+          </a:effectRef>
+          <a:fontRef idx="minor">
+            <a:schemeClr val="lt1"/>
+          </a:fontRef>
+        </p:style>
+        <p:txBody>
+          <a:bodyPr rtlCol="0" anchor="ctr" wrap="square" lIns="128016" rIns="128016" tIns="73152" bIns="73152"/>
+          <a:lstStyle/>
+          <a:p>
+            <a:pPr algn="ctr">
+              <a:spcAft>
+                <a:spcPts val="300"/>
+              </a:spcAft>
+            </a:pPr>
+            <a:r>
+              <a:rPr sz="1100" b="1">
+                <a:solidFill>
+                  <a:srgbClr val="0E1116"/>
+                </a:solidFill>
+                <a:latin typeface="Menlo"/>
+              </a:rPr>
+              <a:t>4</a:t>
+            </a:r>
+          </a:p>
+        </p:txBody>
+      </p:sp>
+      <p:sp>
+        <p:nvSpPr>
+          <p:cNvPr id="18" name="TextBox 17"/>
+          <p:cNvSpPr txBox="1"/>
+          <p:nvPr/>
+        </p:nvSpPr>
+        <p:spPr>
+          <a:xfrm>
+            <a:off x="987552" y="3529583"/>
+            <a:ext cx="2148840" cy="640080"/>
+          </a:xfrm>
+          <a:prstGeom prst="rect">
+            <a:avLst/>
+          </a:prstGeom>
+          <a:noFill/>
+        </p:spPr>
+        <p:txBody>
+          <a:bodyPr wrap="square" anchor="t">
+            <a:spAutoFit/>
+          </a:bodyPr>
+          <a:lstStyle/>
+          <a:p>
+            <a:pPr algn="l">
+              <a:lnSpc>
+                <a:spcPct val="95000"/>
+              </a:lnSpc>
+              <a:spcAft>
+                <a:spcPts val="0"/>
+              </a:spcAft>
+            </a:pPr>
+            <a:r>
+              <a:rPr sz="1150" b="1">
+                <a:solidFill>
+                  <a:srgbClr val="0E1116"/>
+                </a:solidFill>
+                <a:latin typeface="Helvetica Neue"/>
+              </a:rPr>
+              <a:t>“Do we already know this thing?”</a:t>
+            </a:r>
+          </a:p>
+        </p:txBody>
+      </p:sp>
+      <p:sp>
+        <p:nvSpPr>
+          <p:cNvPr id="19" name="TextBox 18"/>
+          <p:cNvSpPr txBox="1"/>
+          <p:nvPr/>
+        </p:nvSpPr>
+        <p:spPr>
+          <a:xfrm>
+            <a:off x="3246120" y="3511295"/>
+            <a:ext cx="6400800" cy="777240"/>
+          </a:xfrm>
+          <a:prstGeom prst="rect">
+            <a:avLst/>
+          </a:prstGeom>
+          <a:noFill/>
+        </p:spPr>
+        <p:txBody>
+          <a:bodyPr wrap="square" anchor="t">
+            <a:spAutoFit/>
+          </a:bodyPr>
+          <a:lstStyle/>
+          <a:p>
+            <a:pPr algn="l">
+              <a:lnSpc>
+                <a:spcPct val="98000"/>
+              </a:lnSpc>
+              <a:spcAft>
+                <a:spcPts val="0"/>
+              </a:spcAft>
+            </a:pPr>
+            <a:r>
+              <a:rPr sz="900" b="0">
+                <a:solidFill>
+                  <a:srgbClr val="48505C"/>
+                </a:solidFill>
+                <a:latin typeface="Helvetica Neue"/>
+              </a:rPr>
+              <a:t>Three checks, cheapest first: exact same name in the graph db? Very similar name+description in the vector db (score ≥ 0.90 = same, &lt; 0.60 = new)? In between — ask the AI to judge. If it's known, anything new it says (like a better description) becomes a proposed update.</a:t>
+            </a:r>
+          </a:p>
+        </p:txBody>
+      </p:sp>
+      <p:sp>
+        <p:nvSpPr>
+          <p:cNvPr id="20" name="Rounded Rectangle 19"/>
+          <p:cNvSpPr/>
+          <p:nvPr/>
+        </p:nvSpPr>
+        <p:spPr>
+          <a:xfrm>
+            <a:off x="9601200" y="3584447"/>
+            <a:ext cx="822960" cy="274320"/>
           </a:xfrm>
           <a:prstGeom prst="roundRect">
             <a:avLst>
@@ -5351,36 +5431,158 @@
           </a:fontRef>
         </p:style>
         <p:txBody>
-          <a:bodyPr rtlCol="0" anchor="ctr" wrap="square" lIns="109728" rIns="109728" tIns="64008" bIns="64008"/>
+          <a:bodyPr rtlCol="0" anchor="ctr" wrap="square" lIns="128016" rIns="128016" tIns="73152" bIns="73152"/>
           <a:lstStyle/>
           <a:p>
             <a:pPr algn="ctr">
               <a:spcAft>
-                <a:spcPts val="200"/>
-              </a:spcAft>
-            </a:pPr>
-            <a:r>
-              <a:rPr sz="850" b="1">
+                <a:spcPts val="300"/>
+              </a:spcAft>
+            </a:pPr>
+            <a:r>
+              <a:rPr sz="800" b="1">
                 <a:solidFill>
                   <a:srgbClr val="0B7E99"/>
                 </a:solidFill>
                 <a:latin typeface="Menlo"/>
               </a:rPr>
-              <a:t>R neo4j</a:t>
-            </a:r>
-          </a:p>
-        </p:txBody>
-      </p:sp>
-      <p:sp>
-        <p:nvSpPr>
-          <p:cNvPr id="18" name="Rounded Rectangle 17"/>
+              <a:t>graph db</a:t>
+            </a:r>
+          </a:p>
+        </p:txBody>
+      </p:sp>
+      <p:sp>
+        <p:nvSpPr>
+          <p:cNvPr id="21" name="Rounded Rectangle 20"/>
           <p:cNvSpPr/>
           <p:nvPr/>
         </p:nvSpPr>
         <p:spPr>
           <a:xfrm>
-            <a:off x="548640" y="3557016"/>
-            <a:ext cx="384048" cy="256032"/>
+            <a:off x="10488168" y="3584447"/>
+            <a:ext cx="900684" cy="274320"/>
+          </a:xfrm>
+          <a:prstGeom prst="roundRect">
+            <a:avLst>
+              <a:gd name="adj" fmla="val 50000"/>
+            </a:avLst>
+          </a:prstGeom>
+          <a:solidFill>
+            <a:srgbClr val="ECE7F9"/>
+          </a:solidFill>
+          <a:ln w="9525">
+            <a:solidFill>
+              <a:srgbClr val="6D4FC4"/>
+            </a:solidFill>
+          </a:ln>
+          <a:effectLst/>
+        </p:spPr>
+        <p:style>
+          <a:lnRef idx="1">
+            <a:schemeClr val="accent1"/>
+          </a:lnRef>
+          <a:fillRef idx="3">
+            <a:schemeClr val="accent1"/>
+          </a:fillRef>
+          <a:effectRef idx="2">
+            <a:schemeClr val="accent1"/>
+          </a:effectRef>
+          <a:fontRef idx="minor">
+            <a:schemeClr val="lt1"/>
+          </a:fontRef>
+        </p:style>
+        <p:txBody>
+          <a:bodyPr rtlCol="0" anchor="ctr" wrap="square" lIns="128016" rIns="128016" tIns="73152" bIns="73152"/>
+          <a:lstStyle/>
+          <a:p>
+            <a:pPr algn="ctr">
+              <a:spcAft>
+                <a:spcPts val="300"/>
+              </a:spcAft>
+            </a:pPr>
+            <a:r>
+              <a:rPr sz="800" b="1">
+                <a:solidFill>
+                  <a:srgbClr val="6D4FC4"/>
+                </a:solidFill>
+                <a:latin typeface="Menlo"/>
+              </a:rPr>
+              <a:t>vector db</a:t>
+            </a:r>
+          </a:p>
+        </p:txBody>
+      </p:sp>
+      <p:sp>
+        <p:nvSpPr>
+          <p:cNvPr id="22" name="Rounded Rectangle 21"/>
+          <p:cNvSpPr/>
+          <p:nvPr/>
+        </p:nvSpPr>
+        <p:spPr>
+          <a:xfrm>
+            <a:off x="11452860" y="3584447"/>
+            <a:ext cx="356616" cy="274320"/>
+          </a:xfrm>
+          <a:prstGeom prst="roundRect">
+            <a:avLst>
+              <a:gd name="adj" fmla="val 50000"/>
+            </a:avLst>
+          </a:prstGeom>
+          <a:solidFill>
+            <a:srgbClr val="ECE7F9"/>
+          </a:solidFill>
+          <a:ln w="9525">
+            <a:solidFill>
+              <a:srgbClr val="6D4FC4"/>
+            </a:solidFill>
+          </a:ln>
+          <a:effectLst/>
+        </p:spPr>
+        <p:style>
+          <a:lnRef idx="1">
+            <a:schemeClr val="accent1"/>
+          </a:lnRef>
+          <a:fillRef idx="3">
+            <a:schemeClr val="accent1"/>
+          </a:fillRef>
+          <a:effectRef idx="2">
+            <a:schemeClr val="accent1"/>
+          </a:effectRef>
+          <a:fontRef idx="minor">
+            <a:schemeClr val="lt1"/>
+          </a:fontRef>
+        </p:style>
+        <p:txBody>
+          <a:bodyPr rtlCol="0" anchor="ctr" wrap="square" lIns="128016" rIns="128016" tIns="73152" bIns="73152"/>
+          <a:lstStyle/>
+          <a:p>
+            <a:pPr algn="ctr">
+              <a:spcAft>
+                <a:spcPts val="300"/>
+              </a:spcAft>
+            </a:pPr>
+            <a:r>
+              <a:rPr sz="800" b="1">
+                <a:solidFill>
+                  <a:srgbClr val="6D4FC4"/>
+                </a:solidFill>
+                <a:latin typeface="Menlo"/>
+              </a:rPr>
+              <a:t>AI</a:t>
+            </a:r>
+          </a:p>
+        </p:txBody>
+      </p:sp>
+      <p:sp>
+        <p:nvSpPr>
+          <p:cNvPr id="23" name="Rounded Rectangle 22"/>
+          <p:cNvSpPr/>
+          <p:nvPr/>
+        </p:nvSpPr>
+        <p:spPr>
+          <a:xfrm>
+            <a:off x="548640" y="4315968"/>
+            <a:ext cx="310896" cy="310896"/>
           </a:xfrm>
           <a:prstGeom prst="roundRect">
             <a:avLst>
@@ -5412,36 +5614,36 @@
           </a:fontRef>
         </p:style>
         <p:txBody>
-          <a:bodyPr rtlCol="0" anchor="ctr" wrap="square" lIns="109728" rIns="109728" tIns="64008" bIns="64008"/>
+          <a:bodyPr rtlCol="0" anchor="ctr" wrap="square" lIns="128016" rIns="128016" tIns="73152" bIns="73152"/>
           <a:lstStyle/>
           <a:p>
             <a:pPr algn="ctr">
               <a:spcAft>
-                <a:spcPts val="200"/>
-              </a:spcAft>
-            </a:pPr>
-            <a:r>
-              <a:rPr sz="850" b="1">
-                <a:solidFill>
-                  <a:srgbClr val="48505C"/>
+                <a:spcPts val="300"/>
+              </a:spcAft>
+            </a:pPr>
+            <a:r>
+              <a:rPr sz="1100" b="1">
+                <a:solidFill>
+                  <a:srgbClr val="0E1116"/>
                 </a:solidFill>
                 <a:latin typeface="Menlo"/>
               </a:rPr>
-              <a:t>s4</a:t>
-            </a:r>
-          </a:p>
-        </p:txBody>
-      </p:sp>
-      <p:sp>
-        <p:nvSpPr>
-          <p:cNvPr id="19" name="TextBox 18"/>
+              <a:t>5</a:t>
+            </a:r>
+          </a:p>
+        </p:txBody>
+      </p:sp>
+      <p:sp>
+        <p:nvSpPr>
+          <p:cNvPr id="24" name="TextBox 23"/>
           <p:cNvSpPr txBox="1"/>
           <p:nvPr/>
         </p:nvSpPr>
         <p:spPr>
           <a:xfrm>
-            <a:off x="1042415" y="3465576"/>
-            <a:ext cx="1417320" cy="457200"/>
+            <a:off x="987552" y="4279392"/>
+            <a:ext cx="2148840" cy="640080"/>
           </a:xfrm>
           <a:prstGeom prst="rect">
             <a:avLst/>
@@ -5456,34 +5658,34 @@
           <a:p>
             <a:pPr algn="l">
               <a:lnSpc>
-                <a:spcPct val="100000"/>
+                <a:spcPct val="95000"/>
               </a:lnSpc>
               <a:spcAft>
-                <a:spcPts val="400"/>
-              </a:spcAft>
-            </a:pPr>
-            <a:r>
-              <a:rPr sz="1250" b="1">
+                <a:spcPts val="0"/>
+              </a:spcAft>
+            </a:pPr>
+            <a:r>
+              <a:rPr sz="1150" b="1">
                 <a:solidFill>
                   <a:srgbClr val="0E1116"/>
                 </a:solidFill>
                 <a:latin typeface="Helvetica Neue"/>
               </a:rPr>
-              <a:t>Dedup</a:t>
-            </a:r>
-          </a:p>
-        </p:txBody>
-      </p:sp>
-      <p:sp>
-        <p:nvSpPr>
-          <p:cNvPr id="20" name="TextBox 19"/>
+              <a:t>“Does this fact clash with the graph?”</a:t>
+            </a:r>
+          </a:p>
+        </p:txBody>
+      </p:sp>
+      <p:sp>
+        <p:nvSpPr>
+          <p:cNvPr id="25" name="TextBox 24"/>
           <p:cNvSpPr txBox="1"/>
           <p:nvPr/>
         </p:nvSpPr>
         <p:spPr>
           <a:xfrm>
-            <a:off x="2487168" y="3447288"/>
-            <a:ext cx="7086600" cy="713232"/>
+            <a:off x="3246120" y="4261104"/>
+            <a:ext cx="6400800" cy="777240"/>
           </a:xfrm>
           <a:prstGeom prst="rect">
             <a:avLst/>
@@ -5498,34 +5700,34 @@
           <a:p>
             <a:pPr algn="l">
               <a:lnSpc>
-                <a:spcPct val="100000"/>
+                <a:spcPct val="98000"/>
               </a:lnSpc>
               <a:spcAft>
                 <a:spcPts val="0"/>
               </a:spcAft>
             </a:pPr>
             <a:r>
-              <a:rPr sz="950" b="0">
+              <a:rPr sz="900" b="0">
                 <a:solidFill>
                   <a:srgbClr val="48505C"/>
                 </a:solidFill>
                 <a:latin typeface="Helvetica Neue"/>
               </a:rPr>
-              <a:t>exact name → embed name+description, ≥0.90 same / &lt;0.60 new → LLM judge for the band; new info on a known entity → update op (descriptions merge, never overwrite)</a:t>
-            </a:r>
-          </a:p>
-        </p:txBody>
-      </p:sp>
-      <p:sp>
-        <p:nvSpPr>
-          <p:cNvPr id="21" name="Rounded Rectangle 20"/>
+              <a:t>Same fact already stored → just count one more source and keep its quote. A value that changed (new CEO, moved HQ) → close the old fact with an end date. A flat contradiction → flag it; a person MUST look at it.</a:t>
+            </a:r>
+          </a:p>
+        </p:txBody>
+      </p:sp>
+      <p:sp>
+        <p:nvSpPr>
+          <p:cNvPr id="26" name="Rounded Rectangle 25"/>
           <p:cNvSpPr/>
           <p:nvPr/>
         </p:nvSpPr>
         <p:spPr>
           <a:xfrm>
-            <a:off x="9710928" y="3538728"/>
-            <a:ext cx="671169" cy="256032"/>
+            <a:off x="9601200" y="4334255"/>
+            <a:ext cx="822960" cy="274320"/>
           </a:xfrm>
           <a:prstGeom prst="roundRect">
             <a:avLst>
@@ -5557,36 +5759,36 @@
           </a:fontRef>
         </p:style>
         <p:txBody>
-          <a:bodyPr rtlCol="0" anchor="ctr" wrap="square" lIns="109728" rIns="109728" tIns="64008" bIns="64008"/>
+          <a:bodyPr rtlCol="0" anchor="ctr" wrap="square" lIns="128016" rIns="128016" tIns="73152" bIns="73152"/>
           <a:lstStyle/>
           <a:p>
             <a:pPr algn="ctr">
               <a:spcAft>
-                <a:spcPts val="200"/>
-              </a:spcAft>
-            </a:pPr>
-            <a:r>
-              <a:rPr sz="850" b="1">
+                <a:spcPts val="300"/>
+              </a:spcAft>
+            </a:pPr>
+            <a:r>
+              <a:rPr sz="800" b="1">
                 <a:solidFill>
                   <a:srgbClr val="0B7E99"/>
                 </a:solidFill>
                 <a:latin typeface="Menlo"/>
               </a:rPr>
-              <a:t>R neo4j</a:t>
-            </a:r>
-          </a:p>
-        </p:txBody>
-      </p:sp>
-      <p:sp>
-        <p:nvSpPr>
-          <p:cNvPr id="22" name="Rounded Rectangle 21"/>
+              <a:t>graph db</a:t>
+            </a:r>
+          </a:p>
+        </p:txBody>
+      </p:sp>
+      <p:sp>
+        <p:nvSpPr>
+          <p:cNvPr id="27" name="Rounded Rectangle 26"/>
           <p:cNvSpPr/>
           <p:nvPr/>
         </p:nvSpPr>
         <p:spPr>
           <a:xfrm>
-            <a:off x="10455249" y="3538728"/>
-            <a:ext cx="746150" cy="256032"/>
+            <a:off x="10488168" y="4334255"/>
+            <a:ext cx="356616" cy="274320"/>
           </a:xfrm>
           <a:prstGeom prst="roundRect">
             <a:avLst>
@@ -5618,97 +5820,36 @@
           </a:fontRef>
         </p:style>
         <p:txBody>
-          <a:bodyPr rtlCol="0" anchor="ctr" wrap="square" lIns="109728" rIns="109728" tIns="64008" bIns="64008"/>
+          <a:bodyPr rtlCol="0" anchor="ctr" wrap="square" lIns="128016" rIns="128016" tIns="73152" bIns="73152"/>
           <a:lstStyle/>
           <a:p>
             <a:pPr algn="ctr">
               <a:spcAft>
-                <a:spcPts val="200"/>
-              </a:spcAft>
-            </a:pPr>
-            <a:r>
-              <a:rPr sz="850" b="1">
+                <a:spcPts val="300"/>
+              </a:spcAft>
+            </a:pPr>
+            <a:r>
+              <a:rPr sz="800" b="1">
                 <a:solidFill>
                   <a:srgbClr val="6D4FC4"/>
                 </a:solidFill>
                 <a:latin typeface="Menlo"/>
               </a:rPr>
-              <a:t>R qdrant</a:t>
-            </a:r>
-          </a:p>
-        </p:txBody>
-      </p:sp>
-      <p:sp>
-        <p:nvSpPr>
-          <p:cNvPr id="23" name="Rounded Rectangle 22"/>
+              <a:t>AI</a:t>
+            </a:r>
+          </a:p>
+        </p:txBody>
+      </p:sp>
+      <p:sp>
+        <p:nvSpPr>
+          <p:cNvPr id="28" name="Rounded Rectangle 27"/>
           <p:cNvSpPr/>
           <p:nvPr/>
         </p:nvSpPr>
         <p:spPr>
           <a:xfrm>
-            <a:off x="11274550" y="3538728"/>
-            <a:ext cx="371246" cy="256032"/>
-          </a:xfrm>
-          <a:prstGeom prst="roundRect">
-            <a:avLst>
-              <a:gd name="adj" fmla="val 50000"/>
-            </a:avLst>
-          </a:prstGeom>
-          <a:solidFill>
-            <a:srgbClr val="ECE7F9"/>
-          </a:solidFill>
-          <a:ln w="9525">
-            <a:solidFill>
-              <a:srgbClr val="6D4FC4"/>
-            </a:solidFill>
-          </a:ln>
-          <a:effectLst/>
-        </p:spPr>
-        <p:style>
-          <a:lnRef idx="1">
-            <a:schemeClr val="accent1"/>
-          </a:lnRef>
-          <a:fillRef idx="3">
-            <a:schemeClr val="accent1"/>
-          </a:fillRef>
-          <a:effectRef idx="2">
-            <a:schemeClr val="accent1"/>
-          </a:effectRef>
-          <a:fontRef idx="minor">
-            <a:schemeClr val="lt1"/>
-          </a:fontRef>
-        </p:style>
-        <p:txBody>
-          <a:bodyPr rtlCol="0" anchor="ctr" wrap="square" lIns="109728" rIns="109728" tIns="64008" bIns="64008"/>
-          <a:lstStyle/>
-          <a:p>
-            <a:pPr algn="ctr">
-              <a:spcAft>
-                <a:spcPts val="200"/>
-              </a:spcAft>
-            </a:pPr>
-            <a:r>
-              <a:rPr sz="850" b="1">
-                <a:solidFill>
-                  <a:srgbClr val="6D4FC4"/>
-                </a:solidFill>
-                <a:latin typeface="Menlo"/>
-              </a:rPr>
-              <a:t>LLM</a:t>
-            </a:r>
-          </a:p>
-        </p:txBody>
-      </p:sp>
-      <p:sp>
-        <p:nvSpPr>
-          <p:cNvPr id="24" name="Rounded Rectangle 23"/>
-          <p:cNvSpPr/>
-          <p:nvPr/>
-        </p:nvSpPr>
-        <p:spPr>
-          <a:xfrm>
-            <a:off x="548640" y="4279392"/>
-            <a:ext cx="384048" cy="256032"/>
+            <a:off x="548640" y="5065776"/>
+            <a:ext cx="310896" cy="310896"/>
           </a:xfrm>
           <a:prstGeom prst="roundRect">
             <a:avLst>
@@ -5740,36 +5881,36 @@
           </a:fontRef>
         </p:style>
         <p:txBody>
-          <a:bodyPr rtlCol="0" anchor="ctr" wrap="square" lIns="109728" rIns="109728" tIns="64008" bIns="64008"/>
+          <a:bodyPr rtlCol="0" anchor="ctr" wrap="square" lIns="128016" rIns="128016" tIns="73152" bIns="73152"/>
           <a:lstStyle/>
           <a:p>
             <a:pPr algn="ctr">
               <a:spcAft>
-                <a:spcPts val="200"/>
-              </a:spcAft>
-            </a:pPr>
-            <a:r>
-              <a:rPr sz="850" b="1">
-                <a:solidFill>
-                  <a:srgbClr val="48505C"/>
+                <a:spcPts val="300"/>
+              </a:spcAft>
+            </a:pPr>
+            <a:r>
+              <a:rPr sz="1100" b="1">
+                <a:solidFill>
+                  <a:srgbClr val="0E1116"/>
                 </a:solidFill>
                 <a:latin typeface="Menlo"/>
               </a:rPr>
-              <a:t>s5</a:t>
-            </a:r>
-          </a:p>
-        </p:txBody>
-      </p:sp>
-      <p:sp>
-        <p:nvSpPr>
-          <p:cNvPr id="25" name="TextBox 24"/>
+              <a:t>6</a:t>
+            </a:r>
+          </a:p>
+        </p:txBody>
+      </p:sp>
+      <p:sp>
+        <p:nvSpPr>
+          <p:cNvPr id="29" name="TextBox 28"/>
           <p:cNvSpPr txBox="1"/>
           <p:nvPr/>
         </p:nvSpPr>
         <p:spPr>
           <a:xfrm>
-            <a:off x="1042415" y="4187952"/>
-            <a:ext cx="1417320" cy="457200"/>
+            <a:off x="987552" y="5029200"/>
+            <a:ext cx="2148840" cy="640080"/>
           </a:xfrm>
           <a:prstGeom prst="rect">
             <a:avLst/>
@@ -5784,34 +5925,34 @@
           <a:p>
             <a:pPr algn="l">
               <a:lnSpc>
-                <a:spcPct val="100000"/>
+                <a:spcPct val="95000"/>
               </a:lnSpc>
               <a:spcAft>
-                <a:spcPts val="400"/>
-              </a:spcAft>
-            </a:pPr>
-            <a:r>
-              <a:rPr sz="1250" b="1">
+                <a:spcPts val="0"/>
+              </a:spcAft>
+            </a:pPr>
+            <a:r>
+              <a:rPr sz="1150" b="1">
                 <a:solidFill>
                   <a:srgbClr val="0E1116"/>
                 </a:solidFill>
                 <a:latin typeface="Helvetica Neue"/>
               </a:rPr>
-              <a:t>Conflicts</a:t>
-            </a:r>
-          </a:p>
-        </p:txBody>
-      </p:sp>
-      <p:sp>
-        <p:nvSpPr>
-          <p:cNvPr id="26" name="TextBox 25"/>
+              <a:t>Score and sort</a:t>
+            </a:r>
+          </a:p>
+        </p:txBody>
+      </p:sp>
+      <p:sp>
+        <p:nvSpPr>
+          <p:cNvPr id="30" name="TextBox 29"/>
           <p:cNvSpPr txBox="1"/>
           <p:nvPr/>
         </p:nvSpPr>
         <p:spPr>
           <a:xfrm>
-            <a:off x="2487168" y="4169664"/>
-            <a:ext cx="7086600" cy="713232"/>
+            <a:off x="3246120" y="5010912"/>
+            <a:ext cx="6400800" cy="777240"/>
           </a:xfrm>
           <a:prstGeom prst="rect">
             <a:avLst/>
@@ -5826,34 +5967,240 @@
           <a:p>
             <a:pPr algn="l">
               <a:lnSpc>
-                <a:spcPct val="100000"/>
+                <a:spcPct val="98000"/>
               </a:lnSpc>
               <a:spcAft>
                 <a:spcPts val="0"/>
               </a:spcAft>
             </a:pPr>
             <a:r>
-              <a:rPr sz="950" b="0">
+              <a:rPr sz="900" b="0">
                 <a:solidFill>
                   <a:srgbClr val="48505C"/>
                 </a:solidFill>
                 <a:latin typeface="Helvetica Neue"/>
               </a:rPr>
-              <a:t>shared endpoint + predicate, different other end → adjudicate: compatible / supersede (auto end-date) / semantic conflict (forced review); exact duplicate → reinforce + append quote</a:t>
-            </a:r>
-          </a:p>
-        </p:txBody>
-      </p:sp>
-      <p:sp>
-        <p:nvSpPr>
-          <p:cNvPr id="27" name="Rounded Rectangle 26"/>
+              <a:t>Every proposed change gets a score. Very confident → auto-approved. Garbage → auto-dropped. Everything else → the review pile. Contradictions and never-seen types always go to review.</a:t>
+            </a:r>
+          </a:p>
+        </p:txBody>
+      </p:sp>
+      <p:sp>
+        <p:nvSpPr>
+          <p:cNvPr id="31" name="Rounded Rectangle 30"/>
           <p:cNvSpPr/>
           <p:nvPr/>
         </p:nvSpPr>
         <p:spPr>
           <a:xfrm>
-            <a:off x="9710928" y="4261104"/>
-            <a:ext cx="671169" cy="256032"/>
+            <a:off x="9601200" y="5084064"/>
+            <a:ext cx="1056132" cy="274320"/>
+          </a:xfrm>
+          <a:prstGeom prst="roundRect">
+            <a:avLst>
+              <a:gd name="adj" fmla="val 50000"/>
+            </a:avLst>
+          </a:prstGeom>
+          <a:solidFill>
+            <a:srgbClr val="F2F4F6"/>
+          </a:solidFill>
+          <a:ln w="9525">
+            <a:solidFill>
+              <a:srgbClr val="CFD5DB"/>
+            </a:solidFill>
+          </a:ln>
+          <a:effectLst/>
+        </p:spPr>
+        <p:style>
+          <a:lnRef idx="1">
+            <a:schemeClr val="accent1"/>
+          </a:lnRef>
+          <a:fillRef idx="3">
+            <a:schemeClr val="accent1"/>
+          </a:fillRef>
+          <a:effectRef idx="2">
+            <a:schemeClr val="accent1"/>
+          </a:effectRef>
+          <a:fontRef idx="minor">
+            <a:schemeClr val="lt1"/>
+          </a:fontRef>
+        </p:style>
+        <p:txBody>
+          <a:bodyPr rtlCol="0" anchor="ctr" wrap="square" lIns="128016" rIns="128016" tIns="73152" bIns="73152"/>
+          <a:lstStyle/>
+          <a:p>
+            <a:pPr algn="ctr">
+              <a:spcAft>
+                <a:spcPts val="300"/>
+              </a:spcAft>
+            </a:pPr>
+            <a:r>
+              <a:rPr sz="800" b="1">
+                <a:solidFill>
+                  <a:srgbClr val="848D9B"/>
+                </a:solidFill>
+                <a:latin typeface="Menlo"/>
+              </a:rPr>
+              <a:t>no database</a:t>
+            </a:r>
+          </a:p>
+        </p:txBody>
+      </p:sp>
+      <p:sp>
+        <p:nvSpPr>
+          <p:cNvPr id="32" name="Rounded Rectangle 31"/>
+          <p:cNvSpPr/>
+          <p:nvPr/>
+        </p:nvSpPr>
+        <p:spPr>
+          <a:xfrm>
+            <a:off x="548640" y="5815584"/>
+            <a:ext cx="310896" cy="310896"/>
+          </a:xfrm>
+          <a:prstGeom prst="roundRect">
+            <a:avLst>
+              <a:gd name="adj" fmla="val 50000"/>
+            </a:avLst>
+          </a:prstGeom>
+          <a:solidFill>
+            <a:srgbClr val="F2F4F6"/>
+          </a:solidFill>
+          <a:ln w="9525">
+            <a:solidFill>
+              <a:srgbClr val="CFD5DB"/>
+            </a:solidFill>
+          </a:ln>
+          <a:effectLst/>
+        </p:spPr>
+        <p:style>
+          <a:lnRef idx="1">
+            <a:schemeClr val="accent1"/>
+          </a:lnRef>
+          <a:fillRef idx="3">
+            <a:schemeClr val="accent1"/>
+          </a:fillRef>
+          <a:effectRef idx="2">
+            <a:schemeClr val="accent1"/>
+          </a:effectRef>
+          <a:fontRef idx="minor">
+            <a:schemeClr val="lt1"/>
+          </a:fontRef>
+        </p:style>
+        <p:txBody>
+          <a:bodyPr rtlCol="0" anchor="ctr" wrap="square" lIns="128016" rIns="128016" tIns="73152" bIns="73152"/>
+          <a:lstStyle/>
+          <a:p>
+            <a:pPr algn="ctr">
+              <a:spcAft>
+                <a:spcPts val="300"/>
+              </a:spcAft>
+            </a:pPr>
+            <a:r>
+              <a:rPr sz="1100" b="1">
+                <a:solidFill>
+                  <a:srgbClr val="0E1116"/>
+                </a:solidFill>
+                <a:latin typeface="Menlo"/>
+              </a:rPr>
+              <a:t>7</a:t>
+            </a:r>
+          </a:p>
+        </p:txBody>
+      </p:sp>
+      <p:sp>
+        <p:nvSpPr>
+          <p:cNvPr id="33" name="TextBox 32"/>
+          <p:cNvSpPr txBox="1"/>
+          <p:nvPr/>
+        </p:nvSpPr>
+        <p:spPr>
+          <a:xfrm>
+            <a:off x="987552" y="5779008"/>
+            <a:ext cx="2148840" cy="640080"/>
+          </a:xfrm>
+          <a:prstGeom prst="rect">
+            <a:avLst/>
+          </a:prstGeom>
+          <a:noFill/>
+        </p:spPr>
+        <p:txBody>
+          <a:bodyPr wrap="square" anchor="t">
+            <a:spAutoFit/>
+          </a:bodyPr>
+          <a:lstStyle/>
+          <a:p>
+            <a:pPr algn="l">
+              <a:lnSpc>
+                <a:spcPct val="95000"/>
+              </a:lnSpc>
+              <a:spcAft>
+                <a:spcPts val="0"/>
+              </a:spcAft>
+            </a:pPr>
+            <a:r>
+              <a:rPr sz="1150" b="1">
+                <a:solidFill>
+                  <a:srgbClr val="0E1116"/>
+                </a:solidFill>
+                <a:latin typeface="Helvetica Neue"/>
+              </a:rPr>
+              <a:t>Save the proposal and stop</a:t>
+            </a:r>
+          </a:p>
+        </p:txBody>
+      </p:sp>
+      <p:sp>
+        <p:nvSpPr>
+          <p:cNvPr id="34" name="TextBox 33"/>
+          <p:cNvSpPr txBox="1"/>
+          <p:nvPr/>
+        </p:nvSpPr>
+        <p:spPr>
+          <a:xfrm>
+            <a:off x="3246120" y="5760720"/>
+            <a:ext cx="6400800" cy="777240"/>
+          </a:xfrm>
+          <a:prstGeom prst="rect">
+            <a:avLst/>
+          </a:prstGeom>
+          <a:noFill/>
+        </p:spPr>
+        <p:txBody>
+          <a:bodyPr wrap="square" anchor="t">
+            <a:spAutoFit/>
+          </a:bodyPr>
+          <a:lstStyle/>
+          <a:p>
+            <a:pPr algn="l">
+              <a:lnSpc>
+                <a:spcPct val="98000"/>
+              </a:lnSpc>
+              <a:spcAft>
+                <a:spcPts val="0"/>
+              </a:spcAft>
+            </a:pPr>
+            <a:r>
+              <a:rPr sz="900" b="0">
+                <a:solidFill>
+                  <a:srgbClr val="48505C"/>
+                </a:solidFill>
+                <a:latin typeface="Helvetica Neue"/>
+              </a:rPr>
+              <a:t>All proposed changes are saved as one JSON document in the waiting room, the run's state goes to Postgres, and the program exits. The graph is untouched. This can sit for a month.</a:t>
+            </a:r>
+          </a:p>
+        </p:txBody>
+      </p:sp>
+      <p:sp>
+        <p:nvSpPr>
+          <p:cNvPr id="35" name="Rounded Rectangle 34"/>
+          <p:cNvSpPr/>
+          <p:nvPr/>
+        </p:nvSpPr>
+        <p:spPr>
+          <a:xfrm>
+            <a:off x="9601200" y="5833872"/>
+            <a:ext cx="1133856" cy="274320"/>
           </a:xfrm>
           <a:prstGeom prst="roundRect">
             <a:avLst>
@@ -5885,97 +6232,36 @@
           </a:fontRef>
         </p:style>
         <p:txBody>
-          <a:bodyPr rtlCol="0" anchor="ctr" wrap="square" lIns="109728" rIns="109728" tIns="64008" bIns="64008"/>
+          <a:bodyPr rtlCol="0" anchor="ctr" wrap="square" lIns="128016" rIns="128016" tIns="73152" bIns="73152"/>
           <a:lstStyle/>
           <a:p>
             <a:pPr algn="ctr">
               <a:spcAft>
-                <a:spcPts val="200"/>
-              </a:spcAft>
-            </a:pPr>
-            <a:r>
-              <a:rPr sz="850" b="1">
+                <a:spcPts val="300"/>
+              </a:spcAft>
+            </a:pPr>
+            <a:r>
+              <a:rPr sz="800" b="1">
                 <a:solidFill>
                   <a:srgbClr val="0B7E99"/>
                 </a:solidFill>
                 <a:latin typeface="Menlo"/>
               </a:rPr>
-              <a:t>R neo4j</a:t>
-            </a:r>
-          </a:p>
-        </p:txBody>
-      </p:sp>
-      <p:sp>
-        <p:nvSpPr>
-          <p:cNvPr id="28" name="Rounded Rectangle 27"/>
+              <a:t>waiting room</a:t>
+            </a:r>
+          </a:p>
+        </p:txBody>
+      </p:sp>
+      <p:sp>
+        <p:nvSpPr>
+          <p:cNvPr id="36" name="Rounded Rectangle 35"/>
           <p:cNvSpPr/>
           <p:nvPr/>
         </p:nvSpPr>
         <p:spPr>
           <a:xfrm>
-            <a:off x="10455249" y="4261104"/>
-            <a:ext cx="371246" cy="256032"/>
-          </a:xfrm>
-          <a:prstGeom prst="roundRect">
-            <a:avLst>
-              <a:gd name="adj" fmla="val 50000"/>
-            </a:avLst>
-          </a:prstGeom>
-          <a:solidFill>
-            <a:srgbClr val="ECE7F9"/>
-          </a:solidFill>
-          <a:ln w="9525">
-            <a:solidFill>
-              <a:srgbClr val="6D4FC4"/>
-            </a:solidFill>
-          </a:ln>
-          <a:effectLst/>
-        </p:spPr>
-        <p:style>
-          <a:lnRef idx="1">
-            <a:schemeClr val="accent1"/>
-          </a:lnRef>
-          <a:fillRef idx="3">
-            <a:schemeClr val="accent1"/>
-          </a:fillRef>
-          <a:effectRef idx="2">
-            <a:schemeClr val="accent1"/>
-          </a:effectRef>
-          <a:fontRef idx="minor">
-            <a:schemeClr val="lt1"/>
-          </a:fontRef>
-        </p:style>
-        <p:txBody>
-          <a:bodyPr rtlCol="0" anchor="ctr" wrap="square" lIns="109728" rIns="109728" tIns="64008" bIns="64008"/>
-          <a:lstStyle/>
-          <a:p>
-            <a:pPr algn="ctr">
-              <a:spcAft>
-                <a:spcPts val="200"/>
-              </a:spcAft>
-            </a:pPr>
-            <a:r>
-              <a:rPr sz="850" b="1">
-                <a:solidFill>
-                  <a:srgbClr val="6D4FC4"/>
-                </a:solidFill>
-                <a:latin typeface="Menlo"/>
-              </a:rPr>
-              <a:t>LLM</a:t>
-            </a:r>
-          </a:p>
-        </p:txBody>
-      </p:sp>
-      <p:sp>
-        <p:nvSpPr>
-          <p:cNvPr id="29" name="Rounded Rectangle 28"/>
-          <p:cNvSpPr/>
-          <p:nvPr/>
-        </p:nvSpPr>
-        <p:spPr>
-          <a:xfrm>
-            <a:off x="548640" y="5001768"/>
-            <a:ext cx="384048" cy="256032"/>
+            <a:off x="10799064" y="5833872"/>
+            <a:ext cx="822960" cy="274320"/>
           </a:xfrm>
           <a:prstGeom prst="roundRect">
             <a:avLst>
@@ -6007,36 +6293,36 @@
           </a:fontRef>
         </p:style>
         <p:txBody>
-          <a:bodyPr rtlCol="0" anchor="ctr" wrap="square" lIns="109728" rIns="109728" tIns="64008" bIns="64008"/>
+          <a:bodyPr rtlCol="0" anchor="ctr" wrap="square" lIns="128016" rIns="128016" tIns="73152" bIns="73152"/>
           <a:lstStyle/>
           <a:p>
             <a:pPr algn="ctr">
               <a:spcAft>
-                <a:spcPts val="200"/>
-              </a:spcAft>
-            </a:pPr>
-            <a:r>
-              <a:rPr sz="850" b="1">
-                <a:solidFill>
-                  <a:srgbClr val="48505C"/>
+                <a:spcPts val="300"/>
+              </a:spcAft>
+            </a:pPr>
+            <a:r>
+              <a:rPr sz="800" b="1">
+                <a:solidFill>
+                  <a:srgbClr val="848D9B"/>
                 </a:solidFill>
                 <a:latin typeface="Menlo"/>
               </a:rPr>
-              <a:t>s6</a:t>
-            </a:r>
-          </a:p>
-        </p:txBody>
-      </p:sp>
-      <p:sp>
-        <p:nvSpPr>
-          <p:cNvPr id="30" name="TextBox 29"/>
+              <a:t>Postgres</a:t>
+            </a:r>
+          </a:p>
+        </p:txBody>
+      </p:sp>
+      <p:sp>
+        <p:nvSpPr>
+          <p:cNvPr id="37" name="TextBox 36"/>
           <p:cNvSpPr txBox="1"/>
           <p:nvPr/>
         </p:nvSpPr>
         <p:spPr>
           <a:xfrm>
-            <a:off x="1042415" y="4910328"/>
-            <a:ext cx="1417320" cy="457200"/>
+            <a:off x="548640" y="6547104"/>
+            <a:ext cx="11064240" cy="320040"/>
           </a:xfrm>
           <a:prstGeom prst="rect">
             <a:avLst/>
@@ -6058,425 +6344,13 @@
               </a:spcAft>
             </a:pPr>
             <a:r>
-              <a:rPr sz="1250" b="1">
-                <a:solidFill>
-                  <a:srgbClr val="0E1116"/>
-                </a:solidFill>
-                <a:latin typeface="Helvetica Neue"/>
-              </a:rPr>
-              <a:t>Score &amp; route</a:t>
-            </a:r>
-          </a:p>
-        </p:txBody>
-      </p:sp>
-      <p:sp>
-        <p:nvSpPr>
-          <p:cNvPr id="31" name="TextBox 30"/>
-          <p:cNvSpPr txBox="1"/>
-          <p:nvPr/>
-        </p:nvSpPr>
-        <p:spPr>
-          <a:xfrm>
-            <a:off x="2487168" y="4892040"/>
-            <a:ext cx="7086600" cy="713232"/>
-          </a:xfrm>
-          <a:prstGeom prst="rect">
-            <a:avLst/>
-          </a:prstGeom>
-          <a:noFill/>
-        </p:spPr>
-        <p:txBody>
-          <a:bodyPr wrap="square" anchor="t">
-            <a:spAutoFit/>
-          </a:bodyPr>
-          <a:lstStyle/>
-          <a:p>
-            <a:pPr algn="l">
-              <a:lnSpc>
-                <a:spcPct val="100000"/>
-              </a:lnSpc>
-              <a:spcAft>
-                <a:spcPts val="0"/>
-              </a:spcAft>
-            </a:pPr>
-            <a:r>
-              <a:rPr sz="950" b="0">
-                <a:solidFill>
-                  <a:srgbClr val="48505C"/>
-                </a:solidFill>
-                <a:latin typeface="Helvetica Neue"/>
-              </a:rPr>
-              <a:t>weighted blend → auto-approve ≥.92 / review / auto-reject &lt;.30; conflicts and new types always review — arithmetic only</a:t>
-            </a:r>
-          </a:p>
-        </p:txBody>
-      </p:sp>
-      <p:sp>
-        <p:nvSpPr>
-          <p:cNvPr id="32" name="Rounded Rectangle 31"/>
-          <p:cNvSpPr/>
-          <p:nvPr/>
-        </p:nvSpPr>
-        <p:spPr>
-          <a:xfrm>
-            <a:off x="9710928" y="4983480"/>
-            <a:ext cx="1345996" cy="256032"/>
-          </a:xfrm>
-          <a:prstGeom prst="roundRect">
-            <a:avLst>
-              <a:gd name="adj" fmla="val 50000"/>
-            </a:avLst>
-          </a:prstGeom>
-          <a:solidFill>
-            <a:srgbClr val="F2F4F6"/>
-          </a:solidFill>
-          <a:ln w="9525">
-            <a:solidFill>
-              <a:srgbClr val="CFD5DB"/>
-            </a:solidFill>
-          </a:ln>
-          <a:effectLst/>
-        </p:spPr>
-        <p:style>
-          <a:lnRef idx="1">
-            <a:schemeClr val="accent1"/>
-          </a:lnRef>
-          <a:fillRef idx="3">
-            <a:schemeClr val="accent1"/>
-          </a:fillRef>
-          <a:effectRef idx="2">
-            <a:schemeClr val="accent1"/>
-          </a:effectRef>
-          <a:fontRef idx="minor">
-            <a:schemeClr val="lt1"/>
-          </a:fontRef>
-        </p:style>
-        <p:txBody>
-          <a:bodyPr rtlCol="0" anchor="ctr" wrap="square" lIns="109728" rIns="109728" tIns="64008" bIns="64008"/>
-          <a:lstStyle/>
-          <a:p>
-            <a:pPr algn="ctr">
-              <a:spcAft>
-                <a:spcPts val="200"/>
-              </a:spcAft>
-            </a:pPr>
-            <a:r>
-              <a:rPr sz="850" b="1">
-                <a:solidFill>
-                  <a:srgbClr val="48505C"/>
+              <a:rPr sz="1000" b="1">
+                <a:solidFill>
+                  <a:srgbClr val="848D9B"/>
                 </a:solidFill>
                 <a:latin typeface="Menlo"/>
               </a:rPr>
-              <a:t>no store touched</a:t>
-            </a:r>
-          </a:p>
-        </p:txBody>
-      </p:sp>
-      <p:sp>
-        <p:nvSpPr>
-          <p:cNvPr id="33" name="Rounded Rectangle 32"/>
-          <p:cNvSpPr/>
-          <p:nvPr/>
-        </p:nvSpPr>
-        <p:spPr>
-          <a:xfrm>
-            <a:off x="548640" y="5724144"/>
-            <a:ext cx="384048" cy="256032"/>
-          </a:xfrm>
-          <a:prstGeom prst="roundRect">
-            <a:avLst>
-              <a:gd name="adj" fmla="val 50000"/>
-            </a:avLst>
-          </a:prstGeom>
-          <a:solidFill>
-            <a:srgbClr val="F2F4F6"/>
-          </a:solidFill>
-          <a:ln w="9525">
-            <a:solidFill>
-              <a:srgbClr val="CFD5DB"/>
-            </a:solidFill>
-          </a:ln>
-          <a:effectLst/>
-        </p:spPr>
-        <p:style>
-          <a:lnRef idx="1">
-            <a:schemeClr val="accent1"/>
-          </a:lnRef>
-          <a:fillRef idx="3">
-            <a:schemeClr val="accent1"/>
-          </a:fillRef>
-          <a:effectRef idx="2">
-            <a:schemeClr val="accent1"/>
-          </a:effectRef>
-          <a:fontRef idx="minor">
-            <a:schemeClr val="lt1"/>
-          </a:fontRef>
-        </p:style>
-        <p:txBody>
-          <a:bodyPr rtlCol="0" anchor="ctr" wrap="square" lIns="109728" rIns="109728" tIns="64008" bIns="64008"/>
-          <a:lstStyle/>
-          <a:p>
-            <a:pPr algn="ctr">
-              <a:spcAft>
-                <a:spcPts val="200"/>
-              </a:spcAft>
-            </a:pPr>
-            <a:r>
-              <a:rPr sz="850" b="1">
-                <a:solidFill>
-                  <a:srgbClr val="48505C"/>
-                </a:solidFill>
-                <a:latin typeface="Menlo"/>
-              </a:rPr>
-              <a:t>s7</a:t>
-            </a:r>
-          </a:p>
-        </p:txBody>
-      </p:sp>
-      <p:sp>
-        <p:nvSpPr>
-          <p:cNvPr id="34" name="TextBox 33"/>
-          <p:cNvSpPr txBox="1"/>
-          <p:nvPr/>
-        </p:nvSpPr>
-        <p:spPr>
-          <a:xfrm>
-            <a:off x="1042415" y="5632704"/>
-            <a:ext cx="1417320" cy="457200"/>
-          </a:xfrm>
-          <a:prstGeom prst="rect">
-            <a:avLst/>
-          </a:prstGeom>
-          <a:noFill/>
-        </p:spPr>
-        <p:txBody>
-          <a:bodyPr wrap="square" anchor="t">
-            <a:spAutoFit/>
-          </a:bodyPr>
-          <a:lstStyle/>
-          <a:p>
-            <a:pPr algn="l">
-              <a:lnSpc>
-                <a:spcPct val="100000"/>
-              </a:lnSpc>
-              <a:spcAft>
-                <a:spcPts val="400"/>
-              </a:spcAft>
-            </a:pPr>
-            <a:r>
-              <a:rPr sz="1250" b="1">
-                <a:solidFill>
-                  <a:srgbClr val="0E1116"/>
-                </a:solidFill>
-                <a:latin typeface="Helvetica Neue"/>
-              </a:rPr>
-              <a:t>Stage &amp; park</a:t>
-            </a:r>
-          </a:p>
-        </p:txBody>
-      </p:sp>
-      <p:sp>
-        <p:nvSpPr>
-          <p:cNvPr id="35" name="TextBox 34"/>
-          <p:cNvSpPr txBox="1"/>
-          <p:nvPr/>
-        </p:nvSpPr>
-        <p:spPr>
-          <a:xfrm>
-            <a:off x="2487168" y="5614416"/>
-            <a:ext cx="7086600" cy="713232"/>
-          </a:xfrm>
-          <a:prstGeom prst="rect">
-            <a:avLst/>
-          </a:prstGeom>
-          <a:noFill/>
-        </p:spPr>
-        <p:txBody>
-          <a:bodyPr wrap="square" anchor="t">
-            <a:spAutoFit/>
-          </a:bodyPr>
-          <a:lstStyle/>
-          <a:p>
-            <a:pPr algn="l">
-              <a:lnSpc>
-                <a:spcPct val="100000"/>
-              </a:lnSpc>
-              <a:spcAft>
-                <a:spcPts val="0"/>
-              </a:spcAft>
-            </a:pPr>
-            <a:r>
-              <a:rPr sz="950" b="0">
-                <a:solidFill>
-                  <a:srgbClr val="48505C"/>
-                </a:solidFill>
-                <a:latin typeface="Helvetica Neue"/>
-              </a:rPr>
-              <a:t>the whole patch persists as ONE JSON blob on a :Patch node — deliberately not graph structure, invisible to search; the run checkpoints and the process exits</a:t>
-            </a:r>
-          </a:p>
-        </p:txBody>
-      </p:sp>
-      <p:sp>
-        <p:nvSpPr>
-          <p:cNvPr id="36" name="Rounded Rectangle 35"/>
-          <p:cNvSpPr/>
-          <p:nvPr/>
-        </p:nvSpPr>
-        <p:spPr>
-          <a:xfrm>
-            <a:off x="9710928" y="5705856"/>
-            <a:ext cx="1271016" cy="256032"/>
-          </a:xfrm>
-          <a:prstGeom prst="roundRect">
-            <a:avLst>
-              <a:gd name="adj" fmla="val 50000"/>
-            </a:avLst>
-          </a:prstGeom>
-          <a:solidFill>
-            <a:srgbClr val="E2EFEC"/>
-          </a:solidFill>
-          <a:ln w="9525">
-            <a:solidFill>
-              <a:srgbClr val="0B7E99"/>
-            </a:solidFill>
-          </a:ln>
-          <a:effectLst/>
-        </p:spPr>
-        <p:style>
-          <a:lnRef idx="1">
-            <a:schemeClr val="accent1"/>
-          </a:lnRef>
-          <a:fillRef idx="3">
-            <a:schemeClr val="accent1"/>
-          </a:fillRef>
-          <a:effectRef idx="2">
-            <a:schemeClr val="accent1"/>
-          </a:effectRef>
-          <a:fontRef idx="minor">
-            <a:schemeClr val="lt1"/>
-          </a:fontRef>
-        </p:style>
-        <p:txBody>
-          <a:bodyPr rtlCol="0" anchor="ctr" wrap="square" lIns="109728" rIns="109728" tIns="64008" bIns="64008"/>
-          <a:lstStyle/>
-          <a:p>
-            <a:pPr algn="ctr">
-              <a:spcAft>
-                <a:spcPts val="200"/>
-              </a:spcAft>
-            </a:pPr>
-            <a:r>
-              <a:rPr sz="850" b="1">
-                <a:solidFill>
-                  <a:srgbClr val="0B7E99"/>
-                </a:solidFill>
-                <a:latin typeface="Menlo"/>
-              </a:rPr>
-              <a:t>W neo4j staging</a:t>
-            </a:r>
-          </a:p>
-        </p:txBody>
-      </p:sp>
-      <p:sp>
-        <p:nvSpPr>
-          <p:cNvPr id="37" name="Rounded Rectangle 36"/>
-          <p:cNvSpPr/>
-          <p:nvPr/>
-        </p:nvSpPr>
-        <p:spPr>
-          <a:xfrm>
-            <a:off x="11055096" y="5705856"/>
-            <a:ext cx="896112" cy="256032"/>
-          </a:xfrm>
-          <a:prstGeom prst="roundRect">
-            <a:avLst>
-              <a:gd name="adj" fmla="val 50000"/>
-            </a:avLst>
-          </a:prstGeom>
-          <a:solidFill>
-            <a:srgbClr val="F2F4F6"/>
-          </a:solidFill>
-          <a:ln w="9525">
-            <a:solidFill>
-              <a:srgbClr val="848D9B"/>
-            </a:solidFill>
-          </a:ln>
-          <a:effectLst/>
-        </p:spPr>
-        <p:style>
-          <a:lnRef idx="1">
-            <a:schemeClr val="accent1"/>
-          </a:lnRef>
-          <a:fillRef idx="3">
-            <a:schemeClr val="accent1"/>
-          </a:fillRef>
-          <a:effectRef idx="2">
-            <a:schemeClr val="accent1"/>
-          </a:effectRef>
-          <a:fontRef idx="minor">
-            <a:schemeClr val="lt1"/>
-          </a:fontRef>
-        </p:style>
-        <p:txBody>
-          <a:bodyPr rtlCol="0" anchor="ctr" wrap="square" lIns="109728" rIns="109728" tIns="64008" bIns="64008"/>
-          <a:lstStyle/>
-          <a:p>
-            <a:pPr algn="ctr">
-              <a:spcAft>
-                <a:spcPts val="200"/>
-              </a:spcAft>
-            </a:pPr>
-            <a:r>
-              <a:rPr sz="850" b="1">
-                <a:solidFill>
-                  <a:srgbClr val="48505C"/>
-                </a:solidFill>
-                <a:latin typeface="Menlo"/>
-              </a:rPr>
-              <a:t>W postgres</a:t>
-            </a:r>
-          </a:p>
-        </p:txBody>
-      </p:sp>
-      <p:sp>
-        <p:nvSpPr>
-          <p:cNvPr id="38" name="TextBox 37"/>
-          <p:cNvSpPr txBox="1"/>
-          <p:nvPr/>
-        </p:nvSpPr>
-        <p:spPr>
-          <a:xfrm>
-            <a:off x="548640" y="6400800"/>
-            <a:ext cx="11064240" cy="365760"/>
-          </a:xfrm>
-          <a:prstGeom prst="rect">
-            <a:avLst/>
-          </a:prstGeom>
-          <a:noFill/>
-        </p:spPr>
-        <p:txBody>
-          <a:bodyPr wrap="square" anchor="t">
-            <a:spAutoFit/>
-          </a:bodyPr>
-          <a:lstStyle/>
-          <a:p>
-            <a:pPr algn="l">
-              <a:lnSpc>
-                <a:spcPct val="100000"/>
-              </a:lnSpc>
-              <a:spcAft>
-                <a:spcPts val="400"/>
-              </a:spcAft>
-            </a:pPr>
-            <a:r>
-              <a:rPr sz="1050" b="1">
-                <a:solidFill>
-                  <a:srgbClr val="848D9B"/>
-                </a:solidFill>
-                <a:latin typeface="Menlo"/>
-              </a:rPr>
-              <a:t>Canonical is byte-for-byte unchanged after s7. Qdrant idle. The patch can sit for a month.</a:t>
+              <a:t>After step 7 the graph db is byte-for-byte unchanged. Proposals are invisible to every search.</a:t>
             </a:r>
           </a:p>
         </p:txBody>
@@ -6580,7 +6454,7 @@
                 </a:solidFill>
                 <a:latin typeface="Menlo"/>
               </a:rPr>
-              <a:t>03 · Ingestion — the gate and the writes</a:t>
+              <a:t>03 · Ingesting a document — part 2</a:t>
             </a:r>
           </a:p>
         </p:txBody>
@@ -6622,7 +6496,7 @@
                 </a:solidFill>
                 <a:latin typeface="Helvetica Neue"/>
               </a:rPr>
-              <a:t>s8–s10 · human decides, commit writes, index follows</a:t>
+              <a:t>A person decides. Then, and only then, we write.</a:t>
             </a:r>
           </a:p>
         </p:txBody>
@@ -6636,7 +6510,7 @@
         <p:spPr>
           <a:xfrm>
             <a:off x="548640" y="1325880"/>
-            <a:ext cx="11530584" cy="1417320"/>
+            <a:ext cx="11530584" cy="1463040"/>
           </a:xfrm>
           <a:prstGeom prst="roundRect">
             <a:avLst>
@@ -6668,63 +6542,38 @@
           </a:fontRef>
         </p:style>
         <p:txBody>
-          <a:bodyPr rtlCol="0" anchor="t" wrap="square" lIns="109728" rIns="109728" tIns="64008" bIns="64008"/>
+          <a:bodyPr rtlCol="0" anchor="t" wrap="square" lIns="128016" rIns="128016" tIns="73152" bIns="73152"/>
           <a:lstStyle/>
           <a:p>
             <a:pPr algn="l">
               <a:spcAft>
-                <a:spcPts val="200"/>
-              </a:spcAft>
-            </a:pPr>
-            <a:r>
-              <a:rPr sz="1200" b="1">
+                <a:spcPts val="300"/>
+              </a:spcAft>
+            </a:pPr>
+            <a:r>
+              <a:rPr sz="1250" b="1">
                 <a:solidFill>
                   <a:srgbClr val="B45309"/>
                 </a:solidFill>
-                <a:latin typeface="Menlo"/>
-              </a:rPr>
-              <a:t>s8 REVIEW — HUMAN</a:t>
-            </a:r>
-            <a:r>
-              <a:rPr sz="1100" b="0">
-                <a:solidFill>
-                  <a:srgbClr val="0E1116"/>
-                </a:solidFill>
-                <a:latin typeface="Helvetica Neue"/>
-              </a:rPr>
-              <a:t>   accept · edit · reject-with-note · defer, per op</a:t>
+                <a:latin typeface="Helvetica Neue"/>
+              </a:rPr>
+              <a:t>8 · REVIEW — a person, in the browser or terminal</a:t>
             </a:r>
           </a:p>
           <a:p>
             <a:pPr algn="l">
               <a:spcAft>
-                <a:spcPts val="200"/>
-              </a:spcAft>
-            </a:pPr>
-            <a:r>
-              <a:rPr sz="950" b="0">
+                <a:spcPts val="300"/>
+              </a:spcAft>
+            </a:pPr>
+            <a:r>
+              <a:rPr sz="1000" b="0">
                 <a:solidFill>
                   <a:srgbClr val="48505C"/>
                 </a:solidFill>
                 <a:latin typeface="Helvetica Neue"/>
               </a:rPr>
-              <a:t>Board groups ops by entity with batch accepts; ⚠-flagged conflicts are excluded from batch actions. Every click becomes a :ReviewDecision. The run resumes from its Postgres checkpoint — CLI or browser, days later.</a:t>
-            </a:r>
-          </a:p>
-          <a:p>
-            <a:pPr algn="l">
-              <a:spcAft>
-                <a:spcPts val="200"/>
-              </a:spcAft>
-            </a:pPr>
-            <a:r>
-              <a:rPr sz="900" b="1">
-                <a:solidFill>
-                  <a:srgbClr val="B45309"/>
-                </a:solidFill>
-                <a:latin typeface="Menlo"/>
-              </a:rPr>
-              <a:t>R/W postgres — resume checkpoint      W neo4j — review decisions</a:t>
+              <a:t>Each proposed change shows its score, its reasoning, and the quote it came from. Approve, fix-then-approve, reject with a note, or skip for later. Changes are grouped by thing (“Acme Corp — 1 new thing + 6 facts” = one click); flagged contradictions can't be bulk-approved. Days may have passed — the run wakes up from Postgres exactly where it stopped.</a:t>
             </a:r>
           </a:p>
         </p:txBody>
@@ -6737,8 +6586,8 @@
         </p:nvSpPr>
         <p:spPr>
           <a:xfrm>
-            <a:off x="548640" y="2907792"/>
-            <a:ext cx="11530584" cy="1737360"/>
+            <a:off x="548640" y="2953512"/>
+            <a:ext cx="11530584" cy="1783080"/>
           </a:xfrm>
           <a:prstGeom prst="roundRect">
             <a:avLst>
@@ -6770,102 +6619,102 @@
           </a:fontRef>
         </p:style>
         <p:txBody>
-          <a:bodyPr rtlCol="0" anchor="t" wrap="square" lIns="109728" rIns="109728" tIns="64008" bIns="64008"/>
+          <a:bodyPr rtlCol="0" anchor="t" wrap="square" lIns="128016" rIns="128016" tIns="73152" bIns="73152"/>
           <a:lstStyle/>
           <a:p>
             <a:pPr algn="l">
               <a:spcAft>
-                <a:spcPts val="200"/>
-              </a:spcAft>
-            </a:pPr>
-            <a:r>
-              <a:rPr sz="1200" b="1">
+                <a:spcPts val="300"/>
+              </a:spcAft>
+            </a:pPr>
+            <a:r>
+              <a:rPr sz="1250" b="1">
                 <a:solidFill>
                   <a:srgbClr val="0B7E99"/>
                 </a:solidFill>
-                <a:latin typeface="Menlo"/>
-              </a:rPr>
-              <a:t>s9 COMMIT — the ONLY writer to canonical</a:t>
+                <a:latin typeface="Helvetica Neue"/>
+              </a:rPr>
+              <a:t>9 · WRITE — the only code that touches the graph db</a:t>
             </a:r>
           </a:p>
           <a:p>
             <a:pPr algn="l">
               <a:spcAft>
-                <a:spcPts val="200"/>
-              </a:spcAft>
-            </a:pPr>
-            <a:r>
-              <a:rPr sz="950" b="0">
+                <a:spcPts val="300"/>
+              </a:spcAft>
+            </a:pPr>
+            <a:r>
+              <a:rPr sz="1000" b="0">
                 <a:solidFill>
                   <a:srgbClr val="48505C"/>
                 </a:solidFill>
                 <a:latin typeface="Helvetica Neue"/>
               </a:rPr>
-              <a:t>One transaction per op, three checks before each write:</a:t>
+              <a:t>One database transaction per approved change, and three safety checks before each write:</a:t>
             </a:r>
           </a:p>
           <a:p>
             <a:pPr algn="l">
               <a:spcAft>
-                <a:spcPts val="200"/>
-              </a:spcAft>
-            </a:pPr>
-            <a:r>
-              <a:rPr sz="950" b="0">
+                <a:spcPts val="300"/>
+              </a:spcAft>
+            </a:pPr>
+            <a:r>
+              <a:rPr sz="1000" b="0">
                 <a:solidFill>
                   <a:srgbClr val="48505C"/>
                 </a:solidFill>
                 <a:latin typeface="Helvetica Neue"/>
               </a:rPr>
-              <a:t>▸ ledger — already applied? skip (crash-and-retry converges; ids minted deterministically)</a:t>
+              <a:t>▸  Did we already write this? (a crash + retry can't create duplicates)</a:t>
             </a:r>
           </a:p>
           <a:p>
             <a:pPr algn="l">
               <a:spcAft>
-                <a:spcPts val="200"/>
-              </a:spcAft>
-            </a:pPr>
-            <a:r>
-              <a:rPr sz="950" b="0">
+                <a:spcPts val="300"/>
+              </a:spcAft>
+            </a:pPr>
+            <a:r>
+              <a:rPr sz="1000" b="0">
                 <a:solidFill>
                   <a:srgbClr val="48505C"/>
                 </a:solidFill>
                 <a:latin typeface="Helvetica Neue"/>
               </a:rPr>
-              <a:t>▸ rebase — assumptions re-verified: edge still absent? node still there? no entity with this name yet (creates)? description unchanged (merges)? — stale ops requeue, never apply blind</a:t>
+              <a:t>▸  Did the graph change while we waited? Each change remembers what the graph looked like when it was proposed — “no thing with this name existed”, “that fact was still open”. If reality moved, the change is sent back for a redo instead of being applied blind.</a:t>
             </a:r>
           </a:p>
           <a:p>
             <a:pPr algn="l">
               <a:spcAft>
-                <a:spcPts val="200"/>
-              </a:spcAft>
-            </a:pPr>
-            <a:r>
-              <a:rPr sz="950" b="0">
+                <a:spcPts val="300"/>
+              </a:spcAft>
+            </a:pPr>
+            <a:r>
+              <a:rPr sz="1000" b="0">
                 <a:solidFill>
                   <a:srgbClr val="48505C"/>
                 </a:solidFill>
                 <a:latin typeface="Helvetica Neue"/>
               </a:rPr>
-              <a:t>▸ dependencies — an edge whose endpoint was rejected is blocked, not written</a:t>
+              <a:t>▸  Was something this depends on rejected? A fact whose endpoint was rejected is skipped.</a:t>
             </a:r>
           </a:p>
           <a:p>
             <a:pPr algn="l">
               <a:spcAft>
-                <a:spcPts val="200"/>
-              </a:spcAft>
-            </a:pPr>
-            <a:r>
-              <a:rPr sz="900" b="1">
-                <a:solidFill>
-                  <a:srgbClr val="0B7E99"/>
-                </a:solidFill>
-                <a:latin typeface="Menlo"/>
-              </a:rPr>
-              <a:t>Deferred ops loop the run back to s8; the doc is only marked done when every op settles.      W neo4j — facts + quotes + ledger + provenance, same transaction</a:t>
+                <a:spcPts val="300"/>
+              </a:spcAft>
+            </a:pPr>
+            <a:r>
+              <a:rPr sz="1000" b="1">
+                <a:solidFill>
+                  <a:srgbClr val="0E1116"/>
+                </a:solidFill>
+                <a:latin typeface="Helvetica Neue"/>
+              </a:rPr>
+              <a:t>The fact and its paper trail (source document, quote, approver) are written together — all or nothing.</a:t>
             </a:r>
           </a:p>
         </p:txBody>
@@ -6878,8 +6727,8 @@
         </p:nvSpPr>
         <p:spPr>
           <a:xfrm>
-            <a:off x="548640" y="4809744"/>
-            <a:ext cx="11530584" cy="1298448"/>
+            <a:off x="548640" y="4901184"/>
+            <a:ext cx="11530584" cy="1234440"/>
           </a:xfrm>
           <a:prstGeom prst="roundRect">
             <a:avLst>
@@ -6887,11 +6736,11 @@
             </a:avLst>
           </a:prstGeom>
           <a:solidFill>
-            <a:srgbClr val="F2F4F6"/>
+            <a:srgbClr val="ECE7F9"/>
           </a:solidFill>
           <a:ln w="9525">
             <a:solidFill>
-              <a:srgbClr val="CFD5DB"/>
+              <a:srgbClr val="6D4FC4"/>
             </a:solidFill>
           </a:ln>
           <a:effectLst/>
@@ -6911,54 +6760,38 @@
           </a:fontRef>
         </p:style>
         <p:txBody>
-          <a:bodyPr rtlCol="0" anchor="t" wrap="square" lIns="109728" rIns="109728" tIns="64008" bIns="64008"/>
+          <a:bodyPr rtlCol="0" anchor="t" wrap="square" lIns="128016" rIns="128016" tIns="73152" bIns="73152"/>
           <a:lstStyle/>
           <a:p>
             <a:pPr algn="l">
               <a:spcAft>
-                <a:spcPts val="200"/>
-              </a:spcAft>
-            </a:pPr>
-            <a:r>
-              <a:rPr sz="1200" b="1">
+                <a:spcPts val="300"/>
+              </a:spcAft>
+            </a:pPr>
+            <a:r>
+              <a:rPr sz="1250" b="1">
                 <a:solidFill>
                   <a:srgbClr val="6D4FC4"/>
                 </a:solidFill>
-                <a:latin typeface="Menlo"/>
-              </a:rPr>
-              <a:t>s10 INDEX — ledger-driven, only what survived the gate</a:t>
+                <a:latin typeface="Helvetica Neue"/>
+              </a:rPr>
+              <a:t>10 · UPDATE THE SEARCH INDEXES</a:t>
             </a:r>
           </a:p>
           <a:p>
             <a:pPr algn="l">
               <a:spcAft>
-                <a:spcPts val="200"/>
-              </a:spcAft>
-            </a:pPr>
-            <a:r>
-              <a:rPr sz="950" b="0">
+                <a:spcPts val="300"/>
+              </a:spcAft>
+            </a:pPr>
+            <a:r>
+              <a:rPr sz="1000" b="0">
                 <a:solidFill>
                   <a:srgbClr val="48505C"/>
                 </a:solidFill>
                 <a:latin typeface="Helvetica Neue"/>
               </a:rPr>
-              <a:t>Commit reads back what THIS patch wrote (via :AppliedOp) and refreshes the three Qdrant collections — an invalidated fact re-embeds with its closed window, a reinforced fact with its new quote, a merged description with its entity. Lucene full-text needs no step: Neo4j maintains it on every write.</a:t>
-            </a:r>
-          </a:p>
-          <a:p>
-            <a:pPr algn="l">
-              <a:spcAft>
-                <a:spcPts val="200"/>
-              </a:spcAft>
-            </a:pPr>
-            <a:r>
-              <a:rPr sz="900" b="1">
-                <a:solidFill>
-                  <a:srgbClr val="6D4FC4"/>
-                </a:solidFill>
-                <a:latin typeface="Menlo"/>
-              </a:rPr>
-              <a:t>W qdrant — kgi-entities / kgi-predicates / kgi-facts      then: :Document hash marked done</a:t>
+              <a:t>The new and changed items are copied into the vector db — names+descriptions, fact sentences with their quotes — so the NEXT document's duplicate-check and everyone's searches can find them. The graph db's own text index updates itself automatically. Skipped changes? The run parks at review again until everything is decided.</a:t>
             </a:r>
           </a:p>
         </p:txBody>
@@ -7062,7 +6895,7 @@
                 </a:solidFill>
                 <a:latin typeface="Menlo"/>
               </a:rPr>
-              <a:t>04 · Query path</a:t>
+              <a:t>04 · Using it</a:t>
             </a:r>
           </a:p>
         </p:txBody>
@@ -7104,7 +6937,7 @@
                 </a:solidFill>
                 <a:latin typeface="Helvetica Neue"/>
               </a:rPr>
-              <a:t>ask &amp; find · three doors, one walk, one grounded answer</a:t>
+              <a:t>Ask a question: search three ways, walk the graph, answer with receipts</a:t>
             </a:r>
           </a:p>
         </p:txBody>
@@ -7117,8 +6950,8 @@
         </p:nvSpPr>
         <p:spPr>
           <a:xfrm>
-            <a:off x="548640" y="1417320"/>
-            <a:ext cx="2286000" cy="548640"/>
+            <a:off x="548640" y="1463040"/>
+            <a:ext cx="2194560" cy="548640"/>
           </a:xfrm>
           <a:prstGeom prst="roundRect">
             <a:avLst>
@@ -7150,23 +6983,22 @@
           </a:fontRef>
         </p:style>
         <p:txBody>
-          <a:bodyPr rtlCol="0" anchor="ctr" wrap="square" lIns="109728" rIns="109728" tIns="64008" bIns="64008"/>
+          <a:bodyPr rtlCol="0" anchor="ctr" wrap="square" lIns="128016" rIns="128016" tIns="73152" bIns="73152"/>
           <a:lstStyle/>
           <a:p>
             <a:pPr algn="ctr">
               <a:spcAft>
-                <a:spcPts val="200"/>
-              </a:spcAft>
-            </a:pPr>
-            <a:r>
-              <a:rPr sz="1000" b="1">
+                <a:spcPts val="300"/>
+              </a:spcAft>
+            </a:pPr>
+            <a:r>
+              <a:rPr sz="1100" b="1">
                 <a:solidFill>
                   <a:srgbClr val="0E1116"/>
                 </a:solidFill>
-                <a:latin typeface="Menlo"/>
-              </a:rPr>
-              <a:t>question
-(optional --as-of)</a:t>
+                <a:latin typeface="Helvetica Neue"/>
+              </a:rPr>
+              <a:t>your question</a:t>
             </a:r>
           </a:p>
         </p:txBody>
@@ -7179,8 +7011,8 @@
         </p:nvSpPr>
         <p:spPr>
           <a:xfrm>
-            <a:off x="548640" y="2286000"/>
-            <a:ext cx="3657600" cy="658368"/>
+            <a:off x="548640" y="2240280"/>
+            <a:ext cx="3977639" cy="658368"/>
           </a:xfrm>
           <a:prstGeom prst="roundRect">
             <a:avLst>
@@ -7212,23 +7044,23 @@
           </a:fontRef>
         </p:style>
         <p:txBody>
-          <a:bodyPr rtlCol="0" anchor="ctr" wrap="square" lIns="109728" rIns="109728" tIns="64008" bIns="64008"/>
+          <a:bodyPr rtlCol="0" anchor="ctr" wrap="square" lIns="128016" rIns="128016" tIns="73152" bIns="73152"/>
           <a:lstStyle/>
           <a:p>
             <a:pPr algn="l">
               <a:spcAft>
-                <a:spcPts val="200"/>
-              </a:spcAft>
-            </a:pPr>
-            <a:r>
-              <a:rPr sz="950" b="1">
+                <a:spcPts val="300"/>
+              </a:spcAft>
+            </a:pPr>
+            <a:r>
+              <a:rPr sz="900" b="1">
                 <a:solidFill>
                   <a:srgbClr val="0E1116"/>
                 </a:solidFill>
-                <a:latin typeface="Menlo"/>
-              </a:rPr>
-              <a:t>door 1 · entity vectors — meaning
-R qdrant kgi-entities (name+description)</a:t>
+                <a:latin typeface="Helvetica Neue"/>
+              </a:rPr>
+              <a:t>search 1 — things with a similar meaning
+(“Goya Awards” ≈ “Spanish film prize”)</a:t>
             </a:r>
           </a:p>
         </p:txBody>
@@ -7241,8 +7073,8 @@
         </p:nvSpPr>
         <p:spPr>
           <a:xfrm>
-            <a:off x="548640" y="3063240"/>
-            <a:ext cx="3657600" cy="658368"/>
+            <a:off x="548640" y="3017520"/>
+            <a:ext cx="3977639" cy="658368"/>
           </a:xfrm>
           <a:prstGeom prst="roundRect">
             <a:avLst>
@@ -7274,23 +7106,23 @@
           </a:fontRef>
         </p:style>
         <p:txBody>
-          <a:bodyPr rtlCol="0" anchor="ctr" wrap="square" lIns="109728" rIns="109728" tIns="64008" bIns="64008"/>
+          <a:bodyPr rtlCol="0" anchor="ctr" wrap="square" lIns="128016" rIns="128016" tIns="73152" bIns="73152"/>
           <a:lstStyle/>
           <a:p>
             <a:pPr algn="l">
               <a:spcAft>
-                <a:spcPts val="200"/>
-              </a:spcAft>
-            </a:pPr>
-            <a:r>
-              <a:rPr sz="950" b="1">
+                <a:spcPts val="300"/>
+              </a:spcAft>
+            </a:pPr>
+            <a:r>
+              <a:rPr sz="900" b="1">
                 <a:solidFill>
                   <a:srgbClr val="0E1116"/>
                 </a:solidFill>
-                <a:latin typeface="Menlo"/>
-              </a:rPr>
-              <a:t>door 2 · fact vectors — what happened
-R qdrant kgi-facts (rendering+window+quotes)</a:t>
+                <a:latin typeface="Helvetica Neue"/>
+              </a:rPr>
+              <a:t>search 2 — stored facts that sound like the question
+(“what happened on 31 Jan 1891?”)</a:t>
             </a:r>
           </a:p>
         </p:txBody>
@@ -7303,8 +7135,8 @@
         </p:nvSpPr>
         <p:spPr>
           <a:xfrm>
-            <a:off x="548640" y="3840480"/>
-            <a:ext cx="3657600" cy="658368"/>
+            <a:off x="548640" y="3794760"/>
+            <a:ext cx="3977639" cy="658368"/>
           </a:xfrm>
           <a:prstGeom prst="roundRect">
             <a:avLst>
@@ -7336,23 +7168,23 @@
           </a:fontRef>
         </p:style>
         <p:txBody>
-          <a:bodyPr rtlCol="0" anchor="ctr" wrap="square" lIns="109728" rIns="109728" tIns="64008" bIns="64008"/>
+          <a:bodyPr rtlCol="0" anchor="ctr" wrap="square" lIns="128016" rIns="128016" tIns="73152" bIns="73152"/>
           <a:lstStyle/>
           <a:p>
             <a:pPr algn="l">
               <a:spcAft>
-                <a:spcPts val="200"/>
-              </a:spcAft>
-            </a:pPr>
-            <a:r>
-              <a:rPr sz="950" b="1">
+                <a:spcPts val="300"/>
+              </a:spcAft>
+            </a:pPr>
+            <a:r>
+              <a:rPr sz="900" b="1">
                 <a:solidFill>
                   <a:srgbClr val="0E1116"/>
                 </a:solidFill>
-                <a:latin typeface="Menlo"/>
-              </a:rPr>
-              <a:t>door 3 · exact terms — BM25
-R neo4j Lucene (names, descriptions, quotes)</a:t>
+                <a:latin typeface="Helvetica Neue"/>
+              </a:rPr>
+              <a:t>search 3 — the exact words, old-school text search
+(codes, acronyms, dates — vectors are bad at these)</a:t>
             </a:r>
           </a:p>
         </p:txBody>
@@ -7365,8 +7197,8 @@
         </p:nvCxnSpPr>
         <p:spPr>
           <a:xfrm>
-            <a:off x="1691640" y="1965960"/>
-            <a:ext cx="0" cy="301752"/>
+            <a:off x="1645920" y="2011680"/>
+            <a:ext cx="0" cy="210312"/>
           </a:xfrm>
           <a:prstGeom prst="bentConnector3">
             <a:avLst/>
@@ -7401,8 +7233,8 @@
         </p:nvCxnSpPr>
         <p:spPr>
           <a:xfrm>
-            <a:off x="4224528" y="2615184"/>
-            <a:ext cx="603504" cy="777240"/>
+            <a:off x="4544568" y="2569464"/>
+            <a:ext cx="530352" cy="777240"/>
           </a:xfrm>
           <a:prstGeom prst="bentConnector3">
             <a:avLst/>
@@ -7437,8 +7269,8 @@
         </p:nvCxnSpPr>
         <p:spPr>
           <a:xfrm>
-            <a:off x="4224528" y="3392424"/>
-            <a:ext cx="603504" cy="0"/>
+            <a:off x="4544568" y="3346703"/>
+            <a:ext cx="530352" cy="1"/>
           </a:xfrm>
           <a:prstGeom prst="bentConnector3">
             <a:avLst/>
@@ -7473,8 +7305,8 @@
         </p:nvCxnSpPr>
         <p:spPr>
           <a:xfrm flipV="1">
-            <a:off x="4224528" y="3392424"/>
-            <a:ext cx="603504" cy="777240"/>
+            <a:off x="4544568" y="3346704"/>
+            <a:ext cx="530352" cy="777240"/>
           </a:xfrm>
           <a:prstGeom prst="bentConnector3">
             <a:avLst/>
@@ -7509,8 +7341,107 @@
         </p:nvSpPr>
         <p:spPr>
           <a:xfrm>
-            <a:off x="4846320" y="3063240"/>
-            <a:ext cx="1783080" cy="658368"/>
+            <a:off x="5093208" y="3017520"/>
+            <a:ext cx="1828800" cy="658368"/>
+          </a:xfrm>
+          <a:prstGeom prst="roundRect">
+            <a:avLst>
+              <a:gd name="adj" fmla="val 10000"/>
+            </a:avLst>
+          </a:prstGeom>
+          <a:solidFill>
+            <a:srgbClr val="F2F4F6"/>
+          </a:solidFill>
+          <a:ln w="9525">
+            <a:solidFill>
+              <a:srgbClr val="CFD5DB"/>
+            </a:solidFill>
+          </a:ln>
+          <a:effectLst/>
+        </p:spPr>
+        <p:style>
+          <a:lnRef idx="1">
+            <a:schemeClr val="accent1"/>
+          </a:lnRef>
+          <a:fillRef idx="3">
+            <a:schemeClr val="accent1"/>
+          </a:fillRef>
+          <a:effectRef idx="2">
+            <a:schemeClr val="accent1"/>
+          </a:effectRef>
+          <a:fontRef idx="minor">
+            <a:schemeClr val="lt1"/>
+          </a:fontRef>
+        </p:style>
+        <p:txBody>
+          <a:bodyPr rtlCol="0" anchor="ctr" wrap="square" lIns="128016" rIns="128016" tIns="73152" bIns="73152"/>
+          <a:lstStyle/>
+          <a:p>
+            <a:pPr algn="ctr">
+              <a:spcAft>
+                <a:spcPts val="300"/>
+              </a:spcAft>
+            </a:pPr>
+            <a:r>
+              <a:rPr sz="900" b="1">
+                <a:solidFill>
+                  <a:srgbClr val="0E1116"/>
+                </a:solidFill>
+                <a:latin typeface="Helvetica Neue"/>
+              </a:rPr>
+              <a:t>merge the three
+result lists, keep
+the top 10 things</a:t>
+            </a:r>
+          </a:p>
+        </p:txBody>
+      </p:sp>
+      <p:cxnSp>
+        <p:nvCxnSpPr>
+          <p:cNvPr id="14" name="Connector 13"/>
+          <p:cNvCxnSpPr/>
+          <p:nvPr/>
+        </p:nvCxnSpPr>
+        <p:spPr>
+          <a:xfrm>
+            <a:off x="6940296" y="3346704"/>
+            <a:ext cx="512064" cy="0"/>
+          </a:xfrm>
+          <a:prstGeom prst="bentConnector3">
+            <a:avLst/>
+          </a:prstGeom>
+          <a:ln w="15240">
+            <a:solidFill>
+              <a:srgbClr val="848D9B"/>
+            </a:solidFill>
+            <a:tailEnd type="triangle" w="med" len="med"/>
+          </a:ln>
+        </p:spPr>
+        <p:style>
+          <a:lnRef idx="2">
+            <a:schemeClr val="accent1"/>
+          </a:lnRef>
+          <a:fillRef idx="0">
+            <a:schemeClr val="accent1"/>
+          </a:fillRef>
+          <a:effectRef idx="1">
+            <a:schemeClr val="accent1"/>
+          </a:effectRef>
+          <a:fontRef idx="minor">
+            <a:schemeClr val="tx1"/>
+          </a:fontRef>
+        </p:style>
+      </p:cxnSp>
+      <p:sp>
+        <p:nvSpPr>
+          <p:cNvPr id="15" name="Rounded Rectangle 14"/>
+          <p:cNvSpPr/>
+          <p:nvPr/>
+        </p:nvSpPr>
+        <p:spPr>
+          <a:xfrm>
+            <a:off x="7470648" y="2953512"/>
+            <a:ext cx="2103120" cy="786384"/>
           </a:xfrm>
           <a:prstGeom prst="roundRect">
             <a:avLst>
@@ -7542,37 +7473,38 @@
           </a:fontRef>
         </p:style>
         <p:txBody>
-          <a:bodyPr rtlCol="0" anchor="ctr" wrap="square" lIns="109728" rIns="109728" tIns="64008" bIns="64008"/>
+          <a:bodyPr rtlCol="0" anchor="ctr" wrap="square" lIns="128016" rIns="128016" tIns="73152" bIns="73152"/>
           <a:lstStyle/>
           <a:p>
             <a:pPr algn="ctr">
               <a:spcAft>
-                <a:spcPts val="200"/>
-              </a:spcAft>
-            </a:pPr>
-            <a:r>
-              <a:rPr sz="950" b="1">
-                <a:solidFill>
-                  <a:srgbClr val="0B7E99"/>
-                </a:solidFill>
-                <a:latin typeface="Menlo"/>
-              </a:rPr>
-              <a:t>RRF — fuse ranks
-→ top-10 seeds</a:t>
+                <a:spcPts val="300"/>
+              </a:spcAft>
+            </a:pPr>
+            <a:r>
+              <a:rPr sz="900" b="1">
+                <a:solidFill>
+                  <a:srgbClr val="0E1116"/>
+                </a:solidFill>
+                <a:latin typeface="Helvetica Neue"/>
+              </a:rPr>
+              <a:t>collect their facts,
+2 hops out, only facts
+valid at the asked date</a:t>
             </a:r>
           </a:p>
         </p:txBody>
       </p:sp>
       <p:cxnSp>
         <p:nvCxnSpPr>
-          <p:cNvPr id="14" name="Connector 13"/>
+          <p:cNvPr id="16" name="Connector 15"/>
           <p:cNvCxnSpPr/>
           <p:nvPr/>
         </p:nvCxnSpPr>
         <p:spPr>
           <a:xfrm>
-            <a:off x="6647688" y="3392424"/>
-            <a:ext cx="576072" cy="0"/>
+            <a:off x="9592056" y="3346704"/>
+            <a:ext cx="512064" cy="0"/>
           </a:xfrm>
           <a:prstGeom prst="bentConnector3">
             <a:avLst/>
@@ -7601,18 +7533,143 @@
       </p:cxnSp>
       <p:sp>
         <p:nvSpPr>
-          <p:cNvPr id="15" name="Rounded Rectangle 14"/>
+          <p:cNvPr id="17" name="Rounded Rectangle 16"/>
           <p:cNvSpPr/>
           <p:nvPr/>
         </p:nvSpPr>
         <p:spPr>
           <a:xfrm>
-            <a:off x="7242048" y="2999232"/>
-            <a:ext cx="2103120" cy="786384"/>
+            <a:off x="10122408" y="2907792"/>
+            <a:ext cx="1965960" cy="914400"/>
           </a:xfrm>
           <a:prstGeom prst="roundRect">
             <a:avLst>
               <a:gd name="adj" fmla="val 10000"/>
+            </a:avLst>
+          </a:prstGeom>
+          <a:solidFill>
+            <a:srgbClr val="ECE7F9"/>
+          </a:solidFill>
+          <a:ln w="9525">
+            <a:solidFill>
+              <a:srgbClr val="6D4FC4"/>
+            </a:solidFill>
+          </a:ln>
+          <a:effectLst/>
+        </p:spPr>
+        <p:style>
+          <a:lnRef idx="1">
+            <a:schemeClr val="accent1"/>
+          </a:lnRef>
+          <a:fillRef idx="3">
+            <a:schemeClr val="accent1"/>
+          </a:fillRef>
+          <a:effectRef idx="2">
+            <a:schemeClr val="accent1"/>
+          </a:effectRef>
+          <a:fontRef idx="minor">
+            <a:schemeClr val="lt1"/>
+          </a:fontRef>
+        </p:style>
+        <p:txBody>
+          <a:bodyPr rtlCol="0" anchor="ctr" wrap="square" lIns="128016" rIns="128016" tIns="73152" bIns="73152"/>
+          <a:lstStyle/>
+          <a:p>
+            <a:pPr algn="ctr">
+              <a:spcAft>
+                <a:spcPts val="300"/>
+              </a:spcAft>
+            </a:pPr>
+            <a:r>
+              <a:rPr sz="850" b="1">
+                <a:solidFill>
+                  <a:srgbClr val="0E1116"/>
+                </a:solidFill>
+                <a:latin typeface="Helvetica Neue"/>
+              </a:rPr>
+              <a:t>AI writes the answer
+from those facts only
+— must cite them, or
+say “can't answer”</a:t>
+            </a:r>
+          </a:p>
+        </p:txBody>
+      </p:sp>
+      <p:sp>
+        <p:nvSpPr>
+          <p:cNvPr id="18" name="Rounded Rectangle 17"/>
+          <p:cNvSpPr/>
+          <p:nvPr/>
+        </p:nvSpPr>
+        <p:spPr>
+          <a:xfrm>
+            <a:off x="4617720" y="2240280"/>
+            <a:ext cx="900684" cy="274320"/>
+          </a:xfrm>
+          <a:prstGeom prst="roundRect">
+            <a:avLst>
+              <a:gd name="adj" fmla="val 50000"/>
+            </a:avLst>
+          </a:prstGeom>
+          <a:solidFill>
+            <a:srgbClr val="ECE7F9"/>
+          </a:solidFill>
+          <a:ln w="9525">
+            <a:solidFill>
+              <a:srgbClr val="6D4FC4"/>
+            </a:solidFill>
+          </a:ln>
+          <a:effectLst/>
+        </p:spPr>
+        <p:style>
+          <a:lnRef idx="1">
+            <a:schemeClr val="accent1"/>
+          </a:lnRef>
+          <a:fillRef idx="3">
+            <a:schemeClr val="accent1"/>
+          </a:fillRef>
+          <a:effectRef idx="2">
+            <a:schemeClr val="accent1"/>
+          </a:effectRef>
+          <a:fontRef idx="minor">
+            <a:schemeClr val="lt1"/>
+          </a:fontRef>
+        </p:style>
+        <p:txBody>
+          <a:bodyPr rtlCol="0" anchor="ctr" wrap="square" lIns="128016" rIns="128016" tIns="73152" bIns="73152"/>
+          <a:lstStyle/>
+          <a:p>
+            <a:pPr algn="ctr">
+              <a:spcAft>
+                <a:spcPts val="300"/>
+              </a:spcAft>
+            </a:pPr>
+            <a:r>
+              <a:rPr sz="800" b="1">
+                <a:solidFill>
+                  <a:srgbClr val="6D4FC4"/>
+                </a:solidFill>
+                <a:latin typeface="Menlo"/>
+              </a:rPr>
+              <a:t>vector db</a:t>
+            </a:r>
+          </a:p>
+        </p:txBody>
+      </p:sp>
+      <p:sp>
+        <p:nvSpPr>
+          <p:cNvPr id="19" name="Rounded Rectangle 18"/>
+          <p:cNvSpPr/>
+          <p:nvPr/>
+        </p:nvSpPr>
+        <p:spPr>
+          <a:xfrm>
+            <a:off x="4617720" y="4114800"/>
+            <a:ext cx="822960" cy="274320"/>
+          </a:xfrm>
+          <a:prstGeom prst="roundRect">
+            <a:avLst>
+              <a:gd name="adj" fmla="val 50000"/>
             </a:avLst>
           </a:prstGeom>
           <a:solidFill>
@@ -7640,137 +7697,35 @@
           </a:fontRef>
         </p:style>
         <p:txBody>
-          <a:bodyPr rtlCol="0" anchor="ctr" wrap="square" lIns="109728" rIns="109728" tIns="64008" bIns="64008"/>
+          <a:bodyPr rtlCol="0" anchor="ctr" wrap="square" lIns="128016" rIns="128016" tIns="73152" bIns="73152"/>
           <a:lstStyle/>
           <a:p>
             <a:pPr algn="ctr">
               <a:spcAft>
-                <a:spcPts val="200"/>
-              </a:spcAft>
-            </a:pPr>
-            <a:r>
-              <a:rPr sz="900" b="1">
-                <a:solidFill>
-                  <a:srgbClr val="0E1116"/>
+                <a:spcPts val="300"/>
+              </a:spcAft>
+            </a:pPr>
+            <a:r>
+              <a:rPr sz="800" b="1">
+                <a:solidFill>
+                  <a:srgbClr val="0B7E99"/>
                 </a:solidFill>
                 <a:latin typeface="Menlo"/>
               </a:rPr>
-              <a:t>2-hop graph walk
-date filter per edge
-R neo4j — facts+sources</a:t>
-            </a:r>
-          </a:p>
-        </p:txBody>
-      </p:sp>
-      <p:cxnSp>
-        <p:nvCxnSpPr>
-          <p:cNvPr id="16" name="Connector 15"/>
-          <p:cNvCxnSpPr/>
-          <p:nvPr/>
-        </p:nvCxnSpPr>
-        <p:spPr>
-          <a:xfrm>
-            <a:off x="9363456" y="3392424"/>
-            <a:ext cx="566928" cy="0"/>
-          </a:xfrm>
-          <a:prstGeom prst="bentConnector3">
-            <a:avLst/>
-          </a:prstGeom>
-          <a:ln w="15240">
-            <a:solidFill>
-              <a:srgbClr val="848D9B"/>
-            </a:solidFill>
-            <a:tailEnd type="triangle" w="med" len="med"/>
-          </a:ln>
-        </p:spPr>
-        <p:style>
-          <a:lnRef idx="2">
-            <a:schemeClr val="accent1"/>
-          </a:lnRef>
-          <a:fillRef idx="0">
-            <a:schemeClr val="accent1"/>
-          </a:fillRef>
-          <a:effectRef idx="1">
-            <a:schemeClr val="accent1"/>
-          </a:effectRef>
-          <a:fontRef idx="minor">
-            <a:schemeClr val="tx1"/>
-          </a:fontRef>
-        </p:style>
-      </p:cxnSp>
-      <p:sp>
-        <p:nvSpPr>
-          <p:cNvPr id="17" name="Rounded Rectangle 16"/>
+              <a:t>graph db</a:t>
+            </a:r>
+          </a:p>
+        </p:txBody>
+      </p:sp>
+      <p:sp>
+        <p:nvSpPr>
+          <p:cNvPr id="20" name="Rounded Rectangle 19"/>
           <p:cNvSpPr/>
           <p:nvPr/>
         </p:nvSpPr>
         <p:spPr>
           <a:xfrm>
-            <a:off x="9948672" y="2907792"/>
-            <a:ext cx="2103120" cy="969264"/>
-          </a:xfrm>
-          <a:prstGeom prst="roundRect">
-            <a:avLst>
-              <a:gd name="adj" fmla="val 10000"/>
-            </a:avLst>
-          </a:prstGeom>
-          <a:solidFill>
-            <a:srgbClr val="ECE7F9"/>
-          </a:solidFill>
-          <a:ln w="9525">
-            <a:solidFill>
-              <a:srgbClr val="6D4FC4"/>
-            </a:solidFill>
-          </a:ln>
-          <a:effectLst/>
-        </p:spPr>
-        <p:style>
-          <a:lnRef idx="1">
-            <a:schemeClr val="accent1"/>
-          </a:lnRef>
-          <a:fillRef idx="3">
-            <a:schemeClr val="accent1"/>
-          </a:fillRef>
-          <a:effectRef idx="2">
-            <a:schemeClr val="accent1"/>
-          </a:effectRef>
-          <a:fontRef idx="minor">
-            <a:schemeClr val="lt1"/>
-          </a:fontRef>
-        </p:style>
-        <p:txBody>
-          <a:bodyPr rtlCol="0" anchor="ctr" wrap="square" lIns="109728" rIns="109728" tIns="64008" bIns="64008"/>
-          <a:lstStyle/>
-          <a:p>
-            <a:pPr algn="ctr">
-              <a:spcAft>
-                <a:spcPts val="200"/>
-              </a:spcAft>
-            </a:pPr>
-            <a:r>
-              <a:rPr sz="900" b="1">
-                <a:solidFill>
-                  <a:srgbClr val="0E1116"/>
-                </a:solidFill>
-                <a:latin typeface="Menlo"/>
-              </a:rPr>
-              <a:t>LLM composes from
-entity summaries +
-facts + quotes
-→ cites ids or refuses</a:t>
-            </a:r>
-          </a:p>
-        </p:txBody>
-      </p:sp>
-      <p:sp>
-        <p:nvSpPr>
-          <p:cNvPr id="18" name="Rounded Rectangle 17"/>
-          <p:cNvSpPr/>
-          <p:nvPr/>
-        </p:nvSpPr>
-        <p:spPr>
-          <a:xfrm>
-            <a:off x="548640" y="4983480"/>
+            <a:off x="548640" y="5029200"/>
             <a:ext cx="11530584" cy="566928"/>
           </a:xfrm>
           <a:prstGeom prst="roundRect">
@@ -7803,22 +7758,22 @@
           </a:fontRef>
         </p:style>
         <p:txBody>
-          <a:bodyPr rtlCol="0" anchor="ctr" wrap="square" lIns="109728" rIns="109728" tIns="64008" bIns="64008"/>
+          <a:bodyPr rtlCol="0" anchor="ctr" wrap="square" lIns="128016" rIns="128016" tIns="73152" bIns="73152"/>
           <a:lstStyle/>
           <a:p>
             <a:pPr algn="l">
               <a:spcAft>
-                <a:spcPts val="200"/>
-              </a:spcAft>
-            </a:pPr>
-            <a:r>
-              <a:rPr sz="1050" b="1">
+                <a:spcPts val="300"/>
+              </a:spcAft>
+            </a:pPr>
+            <a:r>
+              <a:rPr sz="1100" b="1">
                 <a:solidFill>
                   <a:srgbClr val="0B7E99"/>
                 </a:solidFill>
-                <a:latin typeface="Menlo"/>
-              </a:rPr>
-              <a:t>find</a:t>
+                <a:latin typeface="Helvetica Neue"/>
+              </a:rPr>
+              <a:t>Find </a:t>
             </a:r>
             <a:r>
               <a:rPr sz="1050" b="0">
@@ -7827,16 +7782,16 @@
                 </a:solidFill>
                 <a:latin typeface="Helvetica Neue"/>
               </a:rPr>
-              <a:t>  = the same three doors + walk, minus the LLM — raw facts with provenance, highlighted on the graph canvas. </a:t>
-            </a:r>
-            <a:r>
-              <a:rPr sz="1050" b="1">
+              <a:t>is the same thing without the AI at the end — you get the raw facts, highlighted on the graph, with their sources. </a:t>
+            </a:r>
+            <a:r>
+              <a:rPr sz="1100" b="1">
                 <a:solidFill>
                   <a:srgbClr val="6D4FC4"/>
                 </a:solidFill>
-                <a:latin typeface="Menlo"/>
-              </a:rPr>
-              <a:t>ask</a:t>
+                <a:latin typeface="Helvetica Neue"/>
+              </a:rPr>
+              <a:t>Ask </a:t>
             </a:r>
             <a:r>
               <a:rPr sz="1050" b="0">
@@ -7845,21 +7800,21 @@
                 </a:solidFill>
                 <a:latin typeface="Helvetica Neue"/>
               </a:rPr>
-              <a:t>  adds exactly one LLM call at the end.</a:t>
-            </a:r>
-          </a:p>
-        </p:txBody>
-      </p:sp>
-      <p:sp>
-        <p:nvSpPr>
-          <p:cNvPr id="19" name="Rounded Rectangle 18"/>
+              <a:t>adds exactly one AI call.</a:t>
+            </a:r>
+          </a:p>
+        </p:txBody>
+      </p:sp>
+      <p:sp>
+        <p:nvSpPr>
+          <p:cNvPr id="21" name="Rounded Rectangle 20"/>
           <p:cNvSpPr/>
           <p:nvPr/>
         </p:nvSpPr>
         <p:spPr>
           <a:xfrm>
-            <a:off x="548640" y="5687568"/>
-            <a:ext cx="11530584" cy="685800"/>
+            <a:off x="548640" y="5733288"/>
+            <a:ext cx="11530584" cy="658368"/>
           </a:xfrm>
           <a:prstGeom prst="roundRect">
             <a:avLst>
@@ -7891,22 +7846,22 @@
           </a:fontRef>
         </p:style>
         <p:txBody>
-          <a:bodyPr rtlCol="0" anchor="ctr" wrap="square" lIns="109728" rIns="109728" tIns="64008" bIns="64008"/>
+          <a:bodyPr rtlCol="0" anchor="ctr" wrap="square" lIns="128016" rIns="128016" tIns="73152" bIns="73152"/>
           <a:lstStyle/>
           <a:p>
             <a:pPr algn="l">
               <a:spcAft>
-                <a:spcPts val="200"/>
-              </a:spcAft>
-            </a:pPr>
-            <a:r>
-              <a:rPr sz="1050" b="1">
+                <a:spcPts val="300"/>
+              </a:spcAft>
+            </a:pPr>
+            <a:r>
+              <a:rPr sz="1100" b="1">
                 <a:solidFill>
                   <a:srgbClr val="0E1116"/>
                 </a:solidFill>
-                <a:latin typeface="Menlo"/>
-              </a:rPr>
-              <a:t>--as-of 2024-06-01</a:t>
+                <a:latin typeface="Helvetica Neue"/>
+              </a:rPr>
+              <a:t>Time travel: </a:t>
             </a:r>
             <a:r>
               <a:rPr sz="1050" b="0">
@@ -7915,7 +7870,7 @@
                 </a:solidFill>
                 <a:latin typeface="Helvetica Neue"/>
               </a:rPr>
-              <a:t>  swaps the date filter: instead of “no end date”, keep facts whose window covers that date — the same graph answers current and historical questions, both cited. Scores are never mixed across doors: cosine and BM25 fuse by rank (1/(60+rank)).</a:t>
+              <a:t>facts carry start/end dates and are never deleted. “Where is the HQ?” uses today's facts; add “as of June 2024” and the same graph answers with what was true then — citing the closed fact.</a:t>
             </a:r>
           </a:p>
         </p:txBody>
@@ -8019,7 +7974,7 @@
                 </a:solidFill>
                 <a:latin typeface="Menlo"/>
               </a:rPr>
-              <a:t>05 · Why engineers can trust it</a:t>
+              <a:t>05 · Why this can be trusted</a:t>
             </a:r>
           </a:p>
         </p:txBody>
@@ -8061,7 +8016,7 @@
                 </a:solidFill>
                 <a:latin typeface="Helvetica Neue"/>
               </a:rPr>
-              <a:t>The guarantees, store by store</a:t>
+              <a:t>Four properties, in plain words</a:t>
             </a:r>
           </a:p>
         </p:txBody>
@@ -8075,7 +8030,7 @@
         <p:spPr>
           <a:xfrm>
             <a:off x="548640" y="1371600"/>
-            <a:ext cx="5660136" cy="2194560"/>
+            <a:ext cx="5660136" cy="2240280"/>
           </a:xfrm>
           <a:prstGeom prst="roundRect">
             <a:avLst>
@@ -8107,32 +8062,32 @@
           </a:fontRef>
         </p:style>
         <p:txBody>
-          <a:bodyPr rtlCol="0" anchor="t" wrap="square" lIns="109728" rIns="109728" tIns="64008" bIns="64008"/>
+          <a:bodyPr rtlCol="0" anchor="t" wrap="square" lIns="128016" rIns="128016" tIns="73152" bIns="73152"/>
           <a:lstStyle/>
           <a:p>
             <a:pPr algn="l">
               <a:spcAft>
-                <a:spcPts val="200"/>
-              </a:spcAft>
-            </a:pPr>
-            <a:r>
-              <a:rPr sz="1250" b="1">
-                <a:solidFill>
-                  <a:srgbClr val="0B7E99"/>
-                </a:solidFill>
-                <a:latin typeface="Helvetica Neue"/>
-              </a:rPr>
-              <a:t>One writer, one shape</a:t>
+                <a:spcPts val="300"/>
+              </a:spcAft>
+            </a:pPr>
+            <a:r>
+              <a:rPr sz="1300" b="1">
+                <a:solidFill>
+                  <a:srgbClr val="B45309"/>
+                </a:solidFill>
+                <a:latin typeface="Helvetica Neue"/>
+              </a:rPr>
+              <a:t>Every fact has receipts</a:t>
             </a:r>
           </a:p>
           <a:p>
             <a:pPr algn="l">
               <a:spcAft>
-                <a:spcPts val="200"/>
-              </a:spcAft>
-            </a:pPr>
-            <a:r>
-              <a:rPr sz="400" b="0">
+                <a:spcPts val="300"/>
+              </a:spcAft>
+            </a:pPr>
+            <a:r>
+              <a:rPr sz="500" b="0">
                 <a:solidFill>
                   <a:srgbClr val="48505C"/>
                 </a:solidFill>
@@ -8144,7 +8099,7 @@
           <a:p>
             <a:pPr algn="l">
               <a:spcAft>
-                <a:spcPts val="200"/>
+                <a:spcPts val="300"/>
               </a:spcAft>
             </a:pPr>
             <a:r>
@@ -8154,7 +8109,7 @@
                 </a:solidFill>
                 <a:latin typeface="Helvetica Neue"/>
               </a:rPr>
-              <a:t>Only the commit engine mutates canonical, and staged knowledge exists only as a JSON blob on a :Patch node — no query, no vector search, no dedup can ever see half-approved facts. Staging and canonical share a database, separated by shape.</a:t>
+              <a:t>Click any fact and you see: the exact sentence it came from, the source document, the date it was written, and the person who approved it (or “auto-approved by score”, spelled out). Rejected proposals are kept too, with the reviewer's note — an auditor sees what was claimed and who said no.</a:t>
             </a:r>
           </a:p>
         </p:txBody>
@@ -8168,7 +8123,7 @@
         <p:spPr>
           <a:xfrm>
             <a:off x="6419088" y="1371600"/>
-            <a:ext cx="5660136" cy="2194560"/>
+            <a:ext cx="5660136" cy="2240280"/>
           </a:xfrm>
           <a:prstGeom prst="roundRect">
             <a:avLst>
@@ -8200,32 +8155,32 @@
           </a:fontRef>
         </p:style>
         <p:txBody>
-          <a:bodyPr rtlCol="0" anchor="t" wrap="square" lIns="109728" rIns="109728" tIns="64008" bIns="64008"/>
+          <a:bodyPr rtlCol="0" anchor="t" wrap="square" lIns="128016" rIns="128016" tIns="73152" bIns="73152"/>
           <a:lstStyle/>
           <a:p>
             <a:pPr algn="l">
               <a:spcAft>
-                <a:spcPts val="200"/>
-              </a:spcAft>
-            </a:pPr>
-            <a:r>
-              <a:rPr sz="1250" b="1">
-                <a:solidFill>
-                  <a:srgbClr val="B45309"/>
-                </a:solidFill>
-                <a:latin typeface="Helvetica Neue"/>
-              </a:rPr>
-              <a:t>Every fact is a chain of custody</a:t>
+                <a:spcPts val="300"/>
+              </a:spcAft>
+            </a:pPr>
+            <a:r>
+              <a:rPr sz="1300" b="1">
+                <a:solidFill>
+                  <a:srgbClr val="0B7E99"/>
+                </a:solidFill>
+                <a:latin typeface="Helvetica Neue"/>
+              </a:rPr>
+              <a:t>The AI is quarantined</a:t>
             </a:r>
           </a:p>
           <a:p>
             <a:pPr algn="l">
               <a:spcAft>
-                <a:spcPts val="200"/>
-              </a:spcAft>
-            </a:pPr>
-            <a:r>
-              <a:rPr sz="400" b="0">
+                <a:spcPts val="300"/>
+              </a:spcAft>
+            </a:pPr>
+            <a:r>
+              <a:rPr sz="500" b="0">
                 <a:solidFill>
                   <a:srgbClr val="48505C"/>
                 </a:solidFill>
@@ -8237,7 +8192,7 @@
           <a:p>
             <a:pPr algn="l">
               <a:spcAft>
-                <a:spcPts val="200"/>
+                <a:spcPts val="300"/>
               </a:spcAft>
             </a:pPr>
             <a:r>
@@ -8247,7 +8202,7 @@
                 </a:solidFill>
                 <a:latin typeface="Helvetica Neue"/>
               </a:rPr>
-              <a:t>fact → verbatim quotes → :AppliedOp (patch, run, timestamp) → :Document (file, hash) → :ReviewDecision (who approved, note) — or “auto-approved by policy”, explicitly recorded. Bad data is found via the ledger and fixed forward with new reviewed patches, never hand-edits.</a:t>
+              <a:t>Everything the AI produces goes to a waiting room first. Searches can't see it, the vector db doesn't index it, the next document's duplicate-check ignores it. If the AI hallucinates, the damage is one bad proposal in a review pile — not a wrong fact in the graph.</a:t>
             </a:r>
           </a:p>
         </p:txBody>
@@ -8260,8 +8215,8 @@
         </p:nvSpPr>
         <p:spPr>
           <a:xfrm>
-            <a:off x="548640" y="3703320"/>
-            <a:ext cx="5660136" cy="2194560"/>
+            <a:off x="548640" y="3749039"/>
+            <a:ext cx="5660136" cy="2240280"/>
           </a:xfrm>
           <a:prstGeom prst="roundRect">
             <a:avLst>
@@ -8293,32 +8248,32 @@
           </a:fontRef>
         </p:style>
         <p:txBody>
-          <a:bodyPr rtlCol="0" anchor="t" wrap="square" lIns="109728" rIns="109728" tIns="64008" bIns="64008"/>
+          <a:bodyPr rtlCol="0" anchor="t" wrap="square" lIns="128016" rIns="128016" tIns="73152" bIns="73152"/>
           <a:lstStyle/>
           <a:p>
             <a:pPr algn="l">
               <a:spcAft>
-                <a:spcPts val="200"/>
-              </a:spcAft>
-            </a:pPr>
-            <a:r>
-              <a:rPr sz="1250" b="1">
-                <a:solidFill>
-                  <a:srgbClr val="6D4FC4"/>
-                </a:solidFill>
-                <a:latin typeface="Helvetica Neue"/>
-              </a:rPr>
-              <a:t>Vectors are cattle, the graph is the pet</a:t>
+                <a:spcPts val="300"/>
+              </a:spcAft>
+            </a:pPr>
+            <a:r>
+              <a:rPr sz="1300" b="1">
+                <a:solidFill>
+                  <a:srgbClr val="48505C"/>
+                </a:solidFill>
+                <a:latin typeface="Helvetica Neue"/>
+              </a:rPr>
+              <a:t>Waiting is safe</a:t>
             </a:r>
           </a:p>
           <a:p>
             <a:pPr algn="l">
               <a:spcAft>
-                <a:spcPts val="200"/>
-              </a:spcAft>
-            </a:pPr>
-            <a:r>
-              <a:rPr sz="400" b="0">
+                <a:spcPts val="300"/>
+              </a:spcAft>
+            </a:pPr>
+            <a:r>
+              <a:rPr sz="500" b="0">
                 <a:solidFill>
                   <a:srgbClr val="48505C"/>
                 </a:solidFill>
@@ -8330,7 +8285,7 @@
           <a:p>
             <a:pPr algn="l">
               <a:spcAft>
-                <a:spcPts val="200"/>
+                <a:spcPts val="300"/>
               </a:spcAft>
             </a:pPr>
             <a:r>
@@ -8340,7 +8295,7 @@
                 </a:solidFill>
                 <a:latin typeface="Helvetica Neue"/>
               </a:rPr>
-              <a:t>All three Qdrant collections are derived copies of graph content, refreshed from the commit ledger (stale vectors can't happen silently) and rebuildable from scratch with scripts/reindex_vectors.py after a model change or drift.</a:t>
+              <a:t>Proposals can wait for weeks while other documents land. Before writing, every change is re-checked against today's graph — if someone else already created “Basel” or closed that fact, the change goes back for a redo instead of creating duplicates. The same file can't be queued twice.</a:t>
             </a:r>
           </a:p>
         </p:txBody>
@@ -8353,8 +8308,8 @@
         </p:nvSpPr>
         <p:spPr>
           <a:xfrm>
-            <a:off x="6419088" y="3703320"/>
-            <a:ext cx="5660136" cy="2194560"/>
+            <a:off x="6419088" y="3749039"/>
+            <a:ext cx="5660136" cy="2240280"/>
           </a:xfrm>
           <a:prstGeom prst="roundRect">
             <a:avLst>
@@ -8386,54 +8341,54 @@
           </a:fontRef>
         </p:style>
         <p:txBody>
-          <a:bodyPr rtlCol="0" anchor="t" wrap="square" lIns="109728" rIns="109728" tIns="64008" bIns="64008"/>
+          <a:bodyPr rtlCol="0" anchor="t" wrap="square" lIns="128016" rIns="128016" tIns="73152" bIns="73152"/>
           <a:lstStyle/>
           <a:p>
             <a:pPr algn="l">
               <a:spcAft>
-                <a:spcPts val="200"/>
-              </a:spcAft>
-            </a:pPr>
-            <a:r>
-              <a:rPr sz="1250" b="1">
+                <a:spcPts val="300"/>
+              </a:spcAft>
+            </a:pPr>
+            <a:r>
+              <a:rPr sz="1300" b="1">
+                <a:solidFill>
+                  <a:srgbClr val="6D4FC4"/>
+                </a:solidFill>
+                <a:latin typeface="Helvetica Neue"/>
+              </a:rPr>
+              <a:t>The vector db is disposable</a:t>
+            </a:r>
+          </a:p>
+          <a:p>
+            <a:pPr algn="l">
+              <a:spcAft>
+                <a:spcPts val="300"/>
+              </a:spcAft>
+            </a:pPr>
+            <a:r>
+              <a:rPr sz="500" b="0">
                 <a:solidFill>
                   <a:srgbClr val="48505C"/>
                 </a:solidFill>
                 <a:latin typeface="Helvetica Neue"/>
               </a:rPr>
-              <a:t>Time doesn't corrupt parked work</a:t>
+              <a:t/>
             </a:r>
           </a:p>
           <a:p>
             <a:pPr algn="l">
               <a:spcAft>
-                <a:spcPts val="200"/>
-              </a:spcAft>
-            </a:pPr>
-            <a:r>
-              <a:rPr sz="400" b="0">
+                <a:spcPts val="300"/>
+              </a:spcAft>
+            </a:pPr>
+            <a:r>
+              <a:rPr sz="1050" b="0">
                 <a:solidFill>
                   <a:srgbClr val="48505C"/>
                 </a:solidFill>
                 <a:latin typeface="Helvetica Neue"/>
               </a:rPr>
-              <a:t/>
-            </a:r>
-          </a:p>
-          <a:p>
-            <a:pPr algn="l">
-              <a:spcAft>
-                <a:spcPts val="200"/>
-              </a:spcAft>
-            </a:pPr>
-            <a:r>
-              <a:rPr sz="1050" b="0">
-                <a:solidFill>
-                  <a:srgbClr val="48505C"/>
-                </a:solidFill>
-                <a:latin typeface="Helvetica Neue"/>
-              </a:rPr>
-              <a:t>A patch can wait at the gate for weeks while other documents land. At commit, every op's recorded assumptions are re-checked: a name that now exists, an edge that got superseded, a description that changed — each requeues instead of applying blind. Same doc twice? Refused at intake.</a:t>
+              <a:t>It's a copy, never the source. Wrong embeddings? Suspected drift? Delete all of it and run one script — it rebuilds from the graph db in minutes. Backups only need to cover the graph db.</a:t>
             </a:r>
           </a:p>
         </p:txBody>
@@ -8446,8 +8401,8 @@
         </p:nvSpPr>
         <p:spPr>
           <a:xfrm>
-            <a:off x="548640" y="6080760"/>
-            <a:ext cx="11064240" cy="457200"/>
+            <a:off x="548640" y="6172200"/>
+            <a:ext cx="11064240" cy="365760"/>
           </a:xfrm>
           <a:prstGeom prst="rect">
             <a:avLst/>
@@ -8475,7 +8430,7 @@
                 </a:solidFill>
                 <a:latin typeface="Menlo"/>
               </a:rPr>
-              <a:t>Deliberately deferred: eval harness (top gap), reranking, NLI claim-checking, work queue — see docs/architecture-deck.html for the full status page.</a:t>
+              <a:t>honest gap: no automated quality benchmark yet — measuring extraction accuracy is the next build</a:t>
             </a:r>
           </a:p>
         </p:txBody>

</xml_diff>

<commit_message>
Update walkthrough deck (slide edits)
Co-Authored-By: Claude Fable 5 <noreply@anthropic.com>
Claude-Session: https://claude.ai/code/session_019Ahwu6z4i8eJ32ivnu5GA8
</commit_message>
<xml_diff>
--- a/docs/kgi-database-walkthrough.pptx
+++ b/docs/kgi-database-walkthrough.pptx
@@ -10,12 +10,12 @@
   <p:sldIdLst>
     <p:sldId id="359" r:id="rId2"/>
     <p:sldId id="362" r:id="rId3"/>
-    <p:sldId id="371" r:id="rId4"/>
+    <p:sldId id="390" r:id="rId4"/>
     <p:sldId id="389" r:id="rId5"/>
     <p:sldId id="373" r:id="rId6"/>
     <p:sldId id="378" r:id="rId7"/>
     <p:sldId id="379" r:id="rId8"/>
-    <p:sldId id="376" r:id="rId9"/>
+    <p:sldId id="391" r:id="rId9"/>
     <p:sldId id="381" r:id="rId10"/>
     <p:sldId id="357" r:id="rId11"/>
     <p:sldId id="384" r:id="rId12"/>
@@ -7199,7 +7199,7 @@
                 </a:solidFill>
                 <a:latin typeface="Menlo"/>
               </a:rPr>
-              <a:t>— alfred-nobel.md</a:t>
+              <a:t>— wikipedia_long.md</a:t>
             </a:r>
           </a:p>
           <a:p>
@@ -7718,7 +7718,7 @@
     </p:spTree>
     <p:extLst>
       <p:ext uri="{BB962C8B-B14F-4D97-AF65-F5344CB8AC3E}">
-        <p14:creationId xmlns:p14="http://schemas.microsoft.com/office/powerpoint/2010/main" val="1933906362"/>
+        <p14:creationId xmlns:p14="http://schemas.microsoft.com/office/powerpoint/2010/main" val="4012617896"/>
       </p:ext>
     </p:extLst>
   </p:cSld>
@@ -9498,7 +9498,7 @@
         <p:spPr>
           <a:xfrm>
             <a:off x="548640" y="292608"/>
-            <a:ext cx="8229600" cy="274320"/>
+            <a:ext cx="8229600" cy="246221"/>
           </a:xfrm>
           <a:prstGeom prst="rect">
             <a:avLst/>
@@ -9520,14 +9520,29 @@
               </a:spcAft>
             </a:pPr>
             <a:r>
-              <a:rPr sz="1000" b="1">
+              <a:rPr sz="1000" b="1" dirty="0">
                 <a:solidFill>
                   <a:srgbClr val="0066BE"/>
                 </a:solidFill>
                 <a:latin typeface="Menlo"/>
               </a:rPr>
-              <a:t>04 · Ingestion · checking every thing</a:t>
-            </a:r>
+              <a:t>04 · Ingestion · checking </a:t>
+            </a:r>
+            <a:r>
+              <a:rPr lang="en-US" sz="1000" b="1" dirty="0">
+                <a:solidFill>
+                  <a:srgbClr val="0066BE"/>
+                </a:solidFill>
+                <a:latin typeface="Menlo"/>
+              </a:rPr>
+              <a:t>everything</a:t>
+            </a:r>
+            <a:endParaRPr sz="1000" b="1" dirty="0">
+              <a:solidFill>
+                <a:srgbClr val="0066BE"/>
+              </a:solidFill>
+              <a:latin typeface="Menlo"/>
+            </a:endParaRPr>
           </a:p>
         </p:txBody>
       </p:sp>
@@ -11842,13 +11857,31 @@
               </a:spcAft>
             </a:pPr>
             <a:r>
-              <a:rPr sz="1200" b="1">
+              <a:rPr sz="1200" b="1" dirty="0">
                 <a:solidFill>
                   <a:srgbClr val="00175A"/>
                 </a:solidFill>
                 <a:latin typeface="Helvetica Neue"/>
               </a:rPr>
-              <a:t>The score — who has to look at this?</a:t>
+              <a:t>The score — who </a:t>
+            </a:r>
+            <a:r>
+              <a:rPr lang="en-US" sz="1200" b="1" dirty="0">
+                <a:solidFill>
+                  <a:srgbClr val="00175A"/>
+                </a:solidFill>
+                <a:latin typeface="Helvetica Neue"/>
+              </a:rPr>
+              <a:t>must</a:t>
+            </a:r>
+            <a:r>
+              <a:rPr sz="1200" b="1" dirty="0">
+                <a:solidFill>
+                  <a:srgbClr val="00175A"/>
+                </a:solidFill>
+                <a:latin typeface="Helvetica Neue"/>
+              </a:rPr>
+              <a:t> look at this?</a:t>
             </a:r>
           </a:p>
           <a:p>
@@ -11857,7 +11890,7 @@
                 <a:spcPts val="300"/>
               </a:spcAft>
             </a:pPr>
-            <a:endParaRPr sz="1200" b="1">
+            <a:endParaRPr sz="1200" b="1" dirty="0">
               <a:solidFill>
                 <a:srgbClr val="00175A"/>
               </a:solidFill>
@@ -11871,7 +11904,7 @@
               </a:spcAft>
             </a:pPr>
             <a:r>
-              <a:rPr sz="950" b="0">
+              <a:rPr sz="950" b="0" dirty="0">
                 <a:solidFill>
                   <a:srgbClr val="3E4C63"/>
                 </a:solidFill>
@@ -11886,7 +11919,7 @@
                 <a:spcPts val="300"/>
               </a:spcAft>
             </a:pPr>
-            <a:endParaRPr sz="950" b="0">
+            <a:endParaRPr sz="950" b="0" dirty="0">
               <a:solidFill>
                 <a:srgbClr val="3E4C63"/>
               </a:solidFill>
@@ -11900,7 +11933,7 @@
               </a:spcAft>
             </a:pPr>
             <a:r>
-              <a:rPr sz="950" b="0">
+              <a:rPr sz="950" b="0" dirty="0">
                 <a:solidFill>
                   <a:srgbClr val="00175A"/>
                 </a:solidFill>
@@ -11916,7 +11949,7 @@
               </a:spcAft>
             </a:pPr>
             <a:r>
-              <a:rPr sz="950" b="0">
+              <a:rPr sz="950" b="0" dirty="0">
                 <a:solidFill>
                   <a:srgbClr val="00175A"/>
                 </a:solidFill>
@@ -11932,7 +11965,7 @@
               </a:spcAft>
             </a:pPr>
             <a:r>
-              <a:rPr sz="950" b="0">
+              <a:rPr sz="950" b="0" dirty="0">
                 <a:solidFill>
                   <a:srgbClr val="00175A"/>
                 </a:solidFill>
@@ -11947,7 +11980,7 @@
                 <a:spcPts val="300"/>
               </a:spcAft>
             </a:pPr>
-            <a:endParaRPr sz="950" b="0">
+            <a:endParaRPr sz="950" b="0" dirty="0">
               <a:solidFill>
                 <a:srgbClr val="00175A"/>
               </a:solidFill>
@@ -11961,7 +11994,7 @@
               </a:spcAft>
             </a:pPr>
             <a:r>
-              <a:rPr sz="950" b="0">
+              <a:rPr sz="950" b="0" dirty="0">
                 <a:solidFill>
                   <a:srgbClr val="3E4C63"/>
                 </a:solidFill>
@@ -12747,7 +12780,7 @@
             </a:endParaRPr>
           </a:p>
           <a:p>
-            <a:pPr algn="l">
+            <a:pPr>
               <a:spcAft>
                 <a:spcPts val="300"/>
               </a:spcAft>
@@ -12759,7 +12792,43 @@
                 </a:solidFill>
                 <a:latin typeface="Menlo"/>
               </a:rPr>
-              <a:t>fact    (Alfred Nobel) —patented→ (dynamite)</a:t>
+              <a:t>fact    (Alfred Nobel) </a:t>
+            </a:r>
+            <a:r>
+              <a:rPr lang="en-US" sz="1050" dirty="0">
+                <a:solidFill>
+                  <a:srgbClr val="00175A"/>
+                </a:solidFill>
+                <a:latin typeface="Menlo"/>
+              </a:rPr>
+              <a:t>→  </a:t>
+            </a:r>
+            <a:r>
+              <a:rPr sz="1050" b="0" dirty="0">
+                <a:solidFill>
+                  <a:srgbClr val="00175A"/>
+                </a:solidFill>
+                <a:latin typeface="Menlo"/>
+              </a:rPr>
+              <a:t>patented</a:t>
+            </a:r>
+            <a:r>
+              <a:rPr lang="en-US" sz="1050" b="0" dirty="0">
+                <a:solidFill>
+                  <a:srgbClr val="00175A"/>
+                </a:solidFill>
+                <a:latin typeface="Menlo"/>
+              </a:rPr>
+              <a:t> </a:t>
+            </a:r>
+            <a:r>
+              <a:rPr sz="1050" b="0" dirty="0">
+                <a:solidFill>
+                  <a:srgbClr val="00175A"/>
+                </a:solidFill>
+                <a:latin typeface="Menlo"/>
+              </a:rPr>
+              <a:t>→ (dynamite)</a:t>
             </a:r>
           </a:p>
           <a:p>
@@ -12855,22 +12924,13 @@
               <a:t>        from </a:t>
             </a:r>
             <a:r>
-              <a:rPr sz="1000" b="1" dirty="0" err="1">
+              <a:rPr sz="1000" b="1" dirty="0">
                 <a:solidFill>
                   <a:srgbClr val="5A6577"/>
                 </a:solidFill>
                 <a:latin typeface="Menlo"/>
               </a:rPr>
-              <a:t>alfred-nobel.md</a:t>
-            </a:r>
-            <a:r>
-              <a:rPr sz="1000" b="1" dirty="0">
-                <a:solidFill>
-                  <a:srgbClr val="5A6577"/>
-                </a:solidFill>
-                <a:latin typeface="Menlo"/>
-              </a:rPr>
-              <a:t> </a:t>
+              <a:t>wikipedia_long.md </a:t>
             </a:r>
             <a:r>
               <a:rPr sz="1000" b="0" dirty="0">
@@ -13029,19 +13089,64 @@
             </a:endParaRPr>
           </a:p>
           <a:p>
-            <a:pPr algn="l">
+            <a:pPr>
               <a:spcAft>
                 <a:spcPts val="300"/>
               </a:spcAft>
             </a:pPr>
             <a:r>
+              <a:rPr lang="en-US" sz="1000" dirty="0">
+                <a:solidFill>
+                  <a:srgbClr val="3E4C63"/>
+                </a:solidFill>
+                <a:latin typeface="Helvetica Neue"/>
+              </a:rPr>
+              <a:t>▸ vector of "Alfred Nobel — Swedish chemist, inventor, and philanthropist" </a:t>
+            </a:r>
+          </a:p>
+          <a:p>
+            <a:pPr>
+              <a:spcAft>
+                <a:spcPts val="300"/>
+              </a:spcAft>
+            </a:pPr>
+            <a:r>
+              <a:rPr lang="en-US" sz="1000" dirty="0">
+                <a:solidFill>
+                  <a:srgbClr val="3E4C63"/>
+                </a:solidFill>
+                <a:latin typeface="Helvetica Neue"/>
+              </a:rPr>
+              <a:t>	→ so similar names/descriptions find him</a:t>
+            </a:r>
+          </a:p>
+          <a:p>
+            <a:pPr>
+              <a:spcAft>
+                <a:spcPts val="300"/>
+              </a:spcAft>
+            </a:pPr>
+            <a:endParaRPr sz="1000" b="0" dirty="0">
+              <a:solidFill>
+                <a:srgbClr val="3E4C63"/>
+              </a:solidFill>
+              <a:latin typeface="Helvetica Neue"/>
+            </a:endParaRPr>
+          </a:p>
+          <a:p>
+            <a:pPr algn="l">
+              <a:spcAft>
+                <a:spcPts val="300"/>
+              </a:spcAft>
+            </a:pPr>
+            <a:r>
               <a:rPr sz="1000" b="0" dirty="0">
                 <a:solidFill>
                   <a:srgbClr val="3E4C63"/>
                 </a:solidFill>
                 <a:latin typeface="Helvetica Neue"/>
               </a:rPr>
-              <a:t>▸ vector of “Alfred Nobel — patented dynamite in 1867” </a:t>
+              <a:t>▸ vector of the whole fact sentence + its quote </a:t>
             </a:r>
             <a:endParaRPr lang="en-US" sz="1000" b="0" dirty="0">
               <a:solidFill>
@@ -13075,31 +13180,22 @@
               <a:t>→ </a:t>
             </a:r>
             <a:r>
+              <a:rPr lang="en-US" sz="1000" b="0" i="1" dirty="0">
+                <a:solidFill>
+                  <a:srgbClr val="3E4C63"/>
+                </a:solidFill>
+                <a:latin typeface="Helvetica Neue"/>
+              </a:rPr>
+              <a:t>so,</a:t>
+            </a:r>
+            <a:r>
               <a:rPr sz="1000" b="0" i="1" dirty="0">
                 <a:solidFill>
                   <a:srgbClr val="3E4C63"/>
                 </a:solidFill>
                 <a:latin typeface="Helvetica Neue"/>
               </a:rPr>
-              <a:t>so</a:t>
-            </a:r>
-            <a:r>
-              <a:rPr lang="en-US" sz="1000" b="0" i="1" dirty="0">
-                <a:solidFill>
-                  <a:srgbClr val="3E4C63"/>
-                </a:solidFill>
-                <a:latin typeface="Helvetica Neue"/>
-              </a:rPr>
-              <a:t>,</a:t>
-            </a:r>
-            <a:r>
-              <a:rPr sz="1000" b="0" i="1" dirty="0">
-                <a:solidFill>
-                  <a:srgbClr val="3E4C63"/>
-                </a:solidFill>
-                <a:latin typeface="Helvetica Neue"/>
-              </a:rPr>
-              <a:t> similar names/descriptions find him</a:t>
+              <a:t> questions like “who patented dynamite?” land on it</a:t>
             </a:r>
             <a:endParaRPr lang="en-US" sz="1000" b="0" i="1" dirty="0">
               <a:solidFill>
@@ -13134,7 +13230,7 @@
                 </a:solidFill>
                 <a:latin typeface="Helvetica Neue"/>
               </a:rPr>
-              <a:t>▸ vector of the whole fact sentence + its quote </a:t>
+              <a:t>▸ the graph db's own text index (updates itself) </a:t>
             </a:r>
             <a:endParaRPr lang="en-US" sz="1000" b="0" dirty="0">
               <a:solidFill>
@@ -13168,13 +13264,22 @@
               <a:t>→ </a:t>
             </a:r>
             <a:r>
+              <a:rPr sz="1000" b="0" i="1" dirty="0">
+                <a:solidFill>
+                  <a:srgbClr val="3E4C63"/>
+                </a:solidFill>
+                <a:latin typeface="Helvetica Neue"/>
+              </a:rPr>
+              <a:t>so</a:t>
+            </a:r>
+            <a:r>
               <a:rPr lang="en-US" sz="1000" b="0" i="1" dirty="0">
                 <a:solidFill>
                   <a:srgbClr val="3E4C63"/>
                 </a:solidFill>
                 <a:latin typeface="Helvetica Neue"/>
               </a:rPr>
-              <a:t>so,</a:t>
+              <a:t>,</a:t>
             </a:r>
             <a:r>
               <a:rPr sz="1000" b="0" i="1" dirty="0">
@@ -13183,7 +13288,7 @@
                 </a:solidFill>
                 <a:latin typeface="Helvetica Neue"/>
               </a:rPr>
-              <a:t> questions like “who patented dynamite?” land on it</a:t>
+              <a:t> exact words, codes and dates are findable</a:t>
             </a:r>
             <a:endParaRPr lang="en-US" sz="1000" b="0" i="1" dirty="0">
               <a:solidFill>
@@ -13198,150 +13303,43 @@
                 <a:spcPts val="300"/>
               </a:spcAft>
             </a:pPr>
+            <a:endParaRPr lang="en-US" sz="2000" b="1" dirty="0">
+              <a:solidFill>
+                <a:srgbClr val="0066BE"/>
+              </a:solidFill>
+              <a:latin typeface="Helvetica Neue"/>
+            </a:endParaRPr>
+          </a:p>
+          <a:p>
+            <a:pPr>
+              <a:spcAft>
+                <a:spcPts val="300"/>
+              </a:spcAft>
+            </a:pPr>
+            <a:r>
+              <a:rPr lang="en-US" sz="1000" b="1" dirty="0">
+                <a:solidFill>
+                  <a:srgbClr val="3E4C63"/>
+                </a:solidFill>
+                <a:latin typeface="Helvetica Neue"/>
+              </a:rPr>
+              <a:t>Copies stay fresh </a:t>
+            </a:r>
+            <a:r>
+              <a:rPr lang="en-US" sz="1000" dirty="0">
+                <a:solidFill>
+                  <a:srgbClr val="3E4C63"/>
+                </a:solidFill>
+                <a:latin typeface="Helvetica Neue"/>
+              </a:rPr>
+              <a:t>— copies refresh automatically when facts change: a closed fact re-copies with its end date, an extra source re-copies with its extra quote</a:t>
+            </a:r>
             <a:endParaRPr sz="1000" b="0" dirty="0">
               <a:solidFill>
                 <a:srgbClr val="3E4C63"/>
               </a:solidFill>
               <a:latin typeface="Helvetica Neue"/>
             </a:endParaRPr>
-          </a:p>
-          <a:p>
-            <a:pPr algn="l">
-              <a:spcAft>
-                <a:spcPts val="300"/>
-              </a:spcAft>
-            </a:pPr>
-            <a:r>
-              <a:rPr sz="1000" b="0" dirty="0">
-                <a:solidFill>
-                  <a:srgbClr val="3E4C63"/>
-                </a:solidFill>
-                <a:latin typeface="Helvetica Neue"/>
-              </a:rPr>
-              <a:t>▸ the graph db's own text index (updates itself) </a:t>
-            </a:r>
-            <a:endParaRPr lang="en-US" sz="1000" b="0" dirty="0">
-              <a:solidFill>
-                <a:srgbClr val="3E4C63"/>
-              </a:solidFill>
-              <a:latin typeface="Helvetica Neue"/>
-            </a:endParaRPr>
-          </a:p>
-          <a:p>
-            <a:pPr algn="l">
-              <a:spcAft>
-                <a:spcPts val="300"/>
-              </a:spcAft>
-            </a:pPr>
-            <a:r>
-              <a:rPr lang="en-US" sz="1000" b="0" dirty="0">
-                <a:solidFill>
-                  <a:srgbClr val="3E4C63"/>
-                </a:solidFill>
-                <a:latin typeface="Helvetica Neue"/>
-              </a:rPr>
-              <a:t>	</a:t>
-            </a:r>
-            <a:r>
-              <a:rPr sz="1000" b="0" dirty="0">
-                <a:solidFill>
-                  <a:srgbClr val="3E4C63"/>
-                </a:solidFill>
-                <a:latin typeface="Helvetica Neue"/>
-              </a:rPr>
-              <a:t>→ </a:t>
-            </a:r>
-            <a:r>
-              <a:rPr sz="1000" b="0" i="1" dirty="0">
-                <a:solidFill>
-                  <a:srgbClr val="3E4C63"/>
-                </a:solidFill>
-                <a:latin typeface="Helvetica Neue"/>
-              </a:rPr>
-              <a:t>so</a:t>
-            </a:r>
-            <a:r>
-              <a:rPr lang="en-US" sz="1000" b="0" i="1" dirty="0">
-                <a:solidFill>
-                  <a:srgbClr val="3E4C63"/>
-                </a:solidFill>
-                <a:latin typeface="Helvetica Neue"/>
-              </a:rPr>
-              <a:t>,</a:t>
-            </a:r>
-            <a:r>
-              <a:rPr sz="1000" b="0" i="1" dirty="0">
-                <a:solidFill>
-                  <a:srgbClr val="3E4C63"/>
-                </a:solidFill>
-                <a:latin typeface="Helvetica Neue"/>
-              </a:rPr>
-              <a:t> exact words, codes and dates are findable</a:t>
-            </a:r>
-            <a:endParaRPr lang="en-US" sz="1000" b="0" i="1" dirty="0">
-              <a:solidFill>
-                <a:srgbClr val="3E4C63"/>
-              </a:solidFill>
-              <a:latin typeface="Helvetica Neue"/>
-            </a:endParaRPr>
-          </a:p>
-          <a:p>
-            <a:pPr algn="l">
-              <a:spcAft>
-                <a:spcPts val="300"/>
-              </a:spcAft>
-            </a:pPr>
-            <a:endParaRPr lang="en-US" sz="1000" b="0" dirty="0">
-              <a:solidFill>
-                <a:srgbClr val="3E4C63"/>
-              </a:solidFill>
-              <a:latin typeface="Helvetica Neue"/>
-            </a:endParaRPr>
-          </a:p>
-          <a:p>
-            <a:pPr algn="l">
-              <a:spcAft>
-                <a:spcPts val="300"/>
-              </a:spcAft>
-            </a:pPr>
-            <a:r>
-              <a:rPr lang="en-US" sz="2000" b="1" i="1" dirty="0">
-                <a:solidFill>
-                  <a:srgbClr val="0066BE"/>
-                </a:solidFill>
-                <a:latin typeface="Helvetica Neue"/>
-              </a:rPr>
-              <a:t>Sync loop</a:t>
-            </a:r>
-          </a:p>
-          <a:p>
-            <a:pPr algn="l">
-              <a:spcAft>
-                <a:spcPts val="300"/>
-              </a:spcAft>
-            </a:pPr>
-            <a:endParaRPr lang="en-US" sz="2000" b="1" dirty="0">
-              <a:solidFill>
-                <a:srgbClr val="0066BE"/>
-              </a:solidFill>
-              <a:latin typeface="Helvetica Neue"/>
-            </a:endParaRPr>
-          </a:p>
-          <a:p>
-            <a:pPr algn="l">
-              <a:spcAft>
-                <a:spcPts val="300"/>
-              </a:spcAft>
-            </a:pPr>
-            <a:r>
-              <a:rPr sz="1000" b="0" dirty="0">
-                <a:solidFill>
-                  <a:srgbClr val="3E4C63"/>
-                </a:solidFill>
-                <a:latin typeface="Helvetica Neue"/>
-              </a:rPr>
-              <a:t>Copies refresh automatically when facts change: a closed fact re-copies with its end date, an extra source re-copies with its extra quote.</a:t>
-            </a:r>
           </a:p>
         </p:txBody>
       </p:sp>
@@ -13503,7 +13501,7 @@
     </p:spTree>
     <p:extLst>
       <p:ext uri="{BB962C8B-B14F-4D97-AF65-F5344CB8AC3E}">
-        <p14:creationId xmlns:p14="http://schemas.microsoft.com/office/powerpoint/2010/main" val="925239062"/>
+        <p14:creationId xmlns:p14="http://schemas.microsoft.com/office/powerpoint/2010/main" val="4009569782"/>
       </p:ext>
     </p:extLst>
   </p:cSld>

</xml_diff>